<commit_message>
feat(examples): audit real thesis and poster visuals
</commit_message>
<xml_diff>
--- a/presentation/ChartAccess_Audit_SYSEN5493_Final.pptx
+++ b/presentation/ChartAccess_Audit_SYSEN5493_Final.pptx
@@ -511,7 +511,7 @@
           <a:p>
             <a:r>
               <a:rPr lang="en-US" dirty="0"/>
-              <a:t>0:00-1:00. Open with the idea that charts are part of decision systems. If a chart is inaccessible, the system excludes people and weakens decisions.</a:t>
+              <a:t>0:00-1:00. Open with the idea that visuals are part of decision systems. If a graph, table, or poster visual is inaccessible, the system excludes people and weakens decisions.</a:t>
             </a:r>
             <a:endParaRPr lang="en-US" dirty="0"/>
           </a:p>
@@ -775,7 +775,7 @@
           <a:p>
             <a:r>
               <a:rPr lang="en-US" dirty="0"/>
-              <a:t>2:00-2:45. Explain the repo architecture and why JSON metadata kept the scope simple and demo-safe.</a:t>
+              <a:t>2:00-2:45. Explain the repo architecture and why the project supports both precise JSON checks and quick PNG upload checks.</a:t>
             </a:r>
             <a:endParaRPr lang="en-US" dirty="0"/>
           </a:p>
@@ -951,7 +951,7 @@
           <a:p>
             <a:r>
               <a:rPr lang="en-US" dirty="0"/>
-              <a:t>3:30-5:30. Live demo commands: python -m chartaccess examples/good_chart.json; python -m chartaccess examples/bad_chart.json; python -m unittest discover -s tests.</a:t>
+              <a:t>3:30-5:30. Live demo commands: python -m chartaccess --image examples/thesis_proximity_consequences.png; python -m chartaccess --image examples/thesis_inaccurate_causes.png; python -m chartaccess --image examples/poster_emotions_table.png. Explain that all three pass automated readability checks, while human review still catches semantic improvements such as legend wording.</a:t>
             </a:r>
             <a:endParaRPr lang="en-US" dirty="0"/>
           </a:p>
@@ -1811,7 +1811,7 @@
                   <a:srgbClr val="D0D7E2"/>
                 </a:solidFill>
               </a:rPr>
-              <a:t>A lightweight AI-augmented workflow that verifies whether graphs are readable, inclusive, and presentation-ready.</a:t>
+              <a:t>A lightweight AI-augmented workflow that verifies whether charts, tables, and presentation graphics are readable, inclusive, and presentation-ready.</a:t>
             </a:r>
             <a:endParaRPr lang="en-US" sz="1800" dirty="0"/>
           </a:p>
@@ -2298,7 +2298,7 @@
                 <a:ea typeface="Aptos Display" pitchFamily="34" charset="-122"/>
                 <a:cs typeface="Aptos Display" pitchFamily="34" charset="-120"/>
               </a:rPr>
-              <a:t>A small checker can make inclusive design part of the workflow.</a:t>
+              <a:t>A small checker can make inclusive visual design part of the workflow.</a:t>
             </a:r>
             <a:endParaRPr lang="en-US" sz="2600" dirty="0"/>
           </a:p>
@@ -2337,7 +2337,7 @@
                   <a:srgbClr val="E4E7EC"/>
                 </a:solidFill>
               </a:rPr>
-              <a:t>The project is cloneable, testable, and CI-ready.</a:t>
+              <a:t>The project is cloneable, testable, CI-ready, and now supports PNG upload.</a:t>
             </a:r>
             <a:endParaRPr lang="en-US" sz="1350" dirty="0"/>
           </a:p>
@@ -2441,7 +2441,7 @@
                   <a:srgbClr val="FFFFFF"/>
                 </a:solidFill>
               </a:rPr>
-              <a:t>Which accessibility checks should become automated gates before engineering reports are shared?</a:t>
+              <a:t>Which inclusive-design checks should become automated gates before reports, posters, or slides are shared?</a:t>
             </a:r>
             <a:endParaRPr lang="en-US" sz="2000" dirty="0"/>
           </a:p>
@@ -2637,7 +2637,7 @@
                 <a:ea typeface="Aptos Display" pitchFamily="34" charset="-122"/>
                 <a:cs typeface="Aptos Display" pitchFamily="34" charset="-120"/>
               </a:rPr>
-              <a:t>Unreadable charts create hidden system failures.</a:t>
+              <a:t>Unreadable visuals create hidden system failures.</a:t>
             </a:r>
             <a:endParaRPr lang="en-US" sz="2600" dirty="0"/>
           </a:p>
@@ -2706,7 +2706,7 @@
                   <a:srgbClr val="172033"/>
                 </a:solidFill>
               </a:rPr>
-              <a:t>The project converts design advice into checks that can run before a chart is shared.</a:t>
+              <a:t>The project converts inclusive design advice into checks that can run before a visual is shared.</a:t>
             </a:r>
             <a:endParaRPr lang="en-US" sz="1350" dirty="0"/>
           </a:p>
@@ -3120,7 +3120,7 @@
                 <a:ea typeface="Aptos Display" pitchFamily="34" charset="-122"/>
                 <a:cs typeface="Aptos Display" pitchFamily="34" charset="-120"/>
               </a:rPr>
-              <a:t>The workflow turns accessibility guidance into verification logic.</a:t>
+              <a:t>The workflow turns inclusive design guidance into verification logic.</a:t>
             </a:r>
             <a:endParaRPr lang="en-US" sz="2600" dirty="0"/>
           </a:p>
@@ -3181,7 +3181,7 @@
                   <a:srgbClr val="005AB5"/>
                 </a:solidFill>
               </a:rPr>
-              <a:t>Chart metadata</a:t>
+              <a:t>Visual input</a:t>
             </a:r>
             <a:endParaRPr lang="en-US" sz="1700" dirty="0"/>
           </a:p>
@@ -3219,7 +3219,7 @@
                   <a:srgbClr val="172033"/>
                 </a:solidFill>
               </a:rPr>
-              <a:t>title, labels, colors, font size, alt text</a:t>
+              <a:t>JSON metadata or uploaded PNG image</a:t>
             </a:r>
             <a:endParaRPr lang="en-US" sz="1200" dirty="0"/>
           </a:p>
@@ -3343,7 +3343,7 @@
                   <a:srgbClr val="172033"/>
                 </a:solidFill>
               </a:rPr>
-              <a:t>contrast, readability, context, screen-reader summary</a:t>
+              <a:t>contrast, readability, color usability, context</a:t>
             </a:r>
             <a:endParaRPr lang="en-US" sz="1200" dirty="0"/>
           </a:p>
@@ -3663,7 +3663,7 @@
                 <a:ea typeface="Aptos Display" pitchFamily="34" charset="-122"/>
                 <a:cs typeface="Aptos Display" pitchFamily="34" charset="-120"/>
               </a:rPr>
-              <a:t>Four simple requirements make the design review testable.</a:t>
+              <a:t>Four simple requirements make inclusive visual review testable.</a:t>
             </a:r>
             <a:endParaRPr lang="en-US" sz="2600" dirty="0"/>
           </a:p>
@@ -4214,7 +4214,7 @@
                 <a:ea typeface="Aptos" pitchFamily="34" charset="-122"/>
                 <a:cs typeface="Aptos" pitchFamily="34" charset="-120"/>
               </a:rPr>
-              <a:t>LIVE DEMO</a:t>
+              <a:t>REAL VISUAL AUDIT</a:t>
             </a:r>
             <a:endParaRPr lang="en-US" sz="900" dirty="0"/>
           </a:p>
@@ -4255,7 +4255,7 @@
                 <a:ea typeface="Aptos Display" pitchFamily="34" charset="-122"/>
                 <a:cs typeface="Aptos Display" pitchFamily="34" charset="-120"/>
               </a:rPr>
-              <a:t>The smallest useful demo compares one passing chart and one failing chart.</a:t>
+              <a:t>The upload workflow passes three real thesis and poster visuals.</a:t>
             </a:r>
             <a:endParaRPr lang="en-US" sz="2600" dirty="0"/>
           </a:p>
@@ -4269,18 +4269,107 @@
         </p:nvSpPr>
         <p:spPr>
           <a:xfrm>
-            <a:off x="685800" y="1691640"/>
-            <a:ext cx="5120640" cy="3429000"/>
-          </a:xfrm>
-          <a:prstGeom prst="rect">
-            <a:avLst/>
+            <a:off x="658368" y="1581912"/>
+            <a:ext cx="2971800" cy="960120"/>
+          </a:xfrm>
+          <a:prstGeom prst="rect">
+            <a:avLst/>
+          </a:prstGeom>
+          <a:solidFill>
+            <a:srgbClr val="FFFFFF"/>
+          </a:solidFill>
+          <a:ln w="12700">
+            <a:solidFill>
+              <a:srgbClr val="CED6E0"/>
+            </a:solidFill>
+            <a:prstDash val="solid"/>
+          </a:ln>
+        </p:spPr>
+      </p:sp>
+      <p:pic>
+        <p:nvPicPr>
+          <p:cNvPr id="6" name="Image 0" descr="examples/thesis_proximity_consequences.png">    </p:cNvPr>
+          <p:cNvPicPr>
+            <a:picLocks noChangeAspect="1"/>
+          </p:cNvPicPr>
+          <p:nvPr/>
+        </p:nvPicPr>
+        <p:blipFill>
+          <a:blip r:embed="rId1"/>
+          <a:stretch>
+            <a:fillRect/>
+          </a:stretch>
+        </p:blipFill>
+        <p:spPr>
+          <a:xfrm>
+            <a:off x="749808" y="1655064"/>
+            <a:ext cx="2788920" cy="777240"/>
+          </a:xfrm>
+          <a:prstGeom prst="rect">
+            <a:avLst/>
+          </a:prstGeom>
+        </p:spPr>
+      </p:pic>
+      <p:sp>
+        <p:nvSpPr>
+          <p:cNvPr id="7" name="Text 4"/>
+          <p:cNvSpPr/>
+          <p:nvPr/>
+        </p:nvSpPr>
+        <p:spPr>
+          <a:xfrm>
+            <a:off x="3840480" y="1645920"/>
+            <a:ext cx="3566160" cy="228600"/>
+          </a:xfrm>
+          <a:prstGeom prst="rect">
+            <a:avLst/>
+          </a:prstGeom>
+          <a:noFill/>
+          <a:ln/>
+        </p:spPr>
+        <p:txBody>
+          <a:bodyPr wrap="square" lIns="0" tIns="0" rIns="0" bIns="0" rtlCol="0" anchor="ctr">
+            <a:normAutofit/>
+          </a:bodyPr>
+          <a:lstStyle/>
+          <a:p>
+            <a:pPr indent="0" marL="0">
+              <a:buNone/>
+            </a:pPr>
+            <a:r>
+              <a:rPr lang="en-US" sz="1320" b="1" dirty="0">
+                <a:solidFill>
+                  <a:srgbClr val="172033"/>
+                </a:solidFill>
+              </a:rPr>
+              <a:t>Thesis: Consequence Proximity</a:t>
+            </a:r>
+            <a:endParaRPr lang="en-US" sz="1320" dirty="0"/>
+          </a:p>
+        </p:txBody>
+      </p:sp>
+      <p:sp>
+        <p:nvSpPr>
+          <p:cNvPr id="8" name="Shape 5"/>
+          <p:cNvSpPr/>
+          <p:nvPr/>
+        </p:nvSpPr>
+        <p:spPr>
+          <a:xfrm>
+            <a:off x="3840480" y="2011680"/>
+            <a:ext cx="4754880" cy="365760"/>
+          </a:xfrm>
+          <a:prstGeom prst="roundRect">
+            <a:avLst>
+              <a:gd name="adj" fmla="val 12500"/>
+            </a:avLst>
           </a:prstGeom>
           <a:solidFill>
             <a:srgbClr val="EAF7F1"/>
           </a:solidFill>
           <a:ln w="12700">
             <a:solidFill>
-              <a:srgbClr val="B7E4CE"/>
+              <a:srgbClr val="EAF7F1"/>
             </a:solidFill>
             <a:prstDash val="solid"/>
           </a:ln>
@@ -4288,59 +4377,23 @@
       </p:sp>
       <p:sp>
         <p:nvSpPr>
-          <p:cNvPr id="6" name="Text 4"/>
-          <p:cNvSpPr/>
-          <p:nvPr/>
-        </p:nvSpPr>
-        <p:spPr>
-          <a:xfrm>
-            <a:off x="960120" y="1920240"/>
-            <a:ext cx="2103120" cy="274320"/>
-          </a:xfrm>
-          <a:prstGeom prst="rect">
-            <a:avLst/>
-          </a:prstGeom>
-          <a:noFill/>
-          <a:ln/>
-        </p:spPr>
-        <p:txBody>
-          <a:bodyPr wrap="square" lIns="0" tIns="0" rIns="0" bIns="0" rtlCol="0" anchor="ctr"/>
-          <a:lstStyle/>
-          <a:p>
-            <a:pPr indent="0" marL="0">
-              <a:buNone/>
-            </a:pPr>
-            <a:r>
-              <a:rPr lang="en-US" sz="1500" b="1" dirty="0">
-                <a:solidFill>
-                  <a:srgbClr val="009E73"/>
-                </a:solidFill>
-              </a:rPr>
-              <a:t>good_chart.json</a:t>
-            </a:r>
-            <a:endParaRPr lang="en-US" sz="1500" dirty="0"/>
-          </a:p>
-        </p:txBody>
-      </p:sp>
-      <p:sp>
-        <p:nvSpPr>
-          <p:cNvPr id="7" name="Text 5"/>
-          <p:cNvSpPr/>
-          <p:nvPr/>
-        </p:nvSpPr>
-        <p:spPr>
-          <a:xfrm>
-            <a:off x="960120" y="2423160"/>
-            <a:ext cx="4343400" cy="1645920"/>
-          </a:xfrm>
-          <a:prstGeom prst="rect">
-            <a:avLst/>
-          </a:prstGeom>
-          <a:noFill/>
-          <a:ln/>
-        </p:spPr>
-        <p:txBody>
-          <a:bodyPr wrap="square" lIns="635" tIns="635" rIns="635" bIns="635" rtlCol="0" anchor="ctr">
+          <p:cNvPr id="9" name="Text 6"/>
+          <p:cNvSpPr/>
+          <p:nvPr/>
+        </p:nvSpPr>
+        <p:spPr>
+          <a:xfrm>
+            <a:off x="3950208" y="2093976"/>
+            <a:ext cx="4535424" cy="164592"/>
+          </a:xfrm>
+          <a:prstGeom prst="rect">
+            <a:avLst/>
+          </a:prstGeom>
+          <a:noFill/>
+          <a:ln/>
+        </p:spPr>
+        <p:txBody>
+          <a:bodyPr wrap="square" lIns="0" tIns="0" rIns="0" bIns="0" rtlCol="0" anchor="ctr">
             <a:normAutofit/>
           </a:bodyPr>
           <a:lstStyle/>
@@ -4349,167 +4402,85 @@
               <a:buNone/>
             </a:pPr>
             <a:r>
-              <a:rPr lang="en-US" sz="1500" dirty="0">
-                <a:solidFill>
-                  <a:srgbClr val="172033"/>
-                </a:solidFill>
-              </a:rPr>
-              <a:t>Score: 4/4</a:t>
-            </a:r>
-            <a:endParaRPr lang="en-US" sz="1500" dirty="0"/>
-          </a:p>
-          <a:p>
-            <a:pPr indent="0" marL="0">
-              <a:buNone/>
-            </a:pPr>
-            <a:r>
-              <a:rPr lang="en-US" sz="1500" dirty="0">
-                <a:solidFill>
-                  <a:srgbClr val="172033"/>
-                </a:solidFill>
-              </a:rPr>
-              <a:t>Overall: PASS</a:t>
-            </a:r>
-            <a:endParaRPr lang="en-US" sz="1500" dirty="0"/>
-          </a:p>
-          <a:p>
-            <a:pPr indent="0" marL="0">
-              <a:buNone/>
-            </a:pPr>
-            <a:r>
-              <a:rPr lang="en-US" sz="1500" dirty="0">
-                <a:solidFill>
-                  <a:srgbClr val="172033"/>
-                </a:solidFill>
-              </a:rPr>
-              <a:t>- contrast passes</a:t>
-            </a:r>
-            <a:endParaRPr lang="en-US" sz="1500" dirty="0"/>
-          </a:p>
-          <a:p>
-            <a:pPr indent="0" marL="0">
-              <a:buNone/>
-            </a:pPr>
-            <a:r>
-              <a:rPr lang="en-US" sz="1500" dirty="0">
-                <a:solidFill>
-                  <a:srgbClr val="172033"/>
-                </a:solidFill>
-              </a:rPr>
-              <a:t>- 13 pt font</a:t>
-            </a:r>
-            <a:endParaRPr lang="en-US" sz="1500" dirty="0"/>
-          </a:p>
-          <a:p>
-            <a:pPr indent="0" marL="0">
-              <a:buNone/>
-            </a:pPr>
-            <a:r>
-              <a:rPr lang="en-US" sz="1500" dirty="0">
-                <a:solidFill>
-                  <a:srgbClr val="172033"/>
-                </a:solidFill>
-              </a:rPr>
-              <a:t>- labels present</a:t>
-            </a:r>
-            <a:endParaRPr lang="en-US" sz="1500" dirty="0"/>
-          </a:p>
-          <a:p>
-            <a:pPr indent="0" marL="0">
-              <a:buNone/>
-            </a:pPr>
-            <a:r>
-              <a:rPr lang="en-US" sz="1500" dirty="0">
-                <a:solidFill>
-                  <a:srgbClr val="172033"/>
-                </a:solidFill>
-              </a:rPr>
-              <a:t>- alt text explains trend</a:t>
-            </a:r>
-            <a:endParaRPr lang="en-US" sz="1500" dirty="0"/>
-          </a:p>
-        </p:txBody>
-      </p:sp>
-      <p:sp>
-        <p:nvSpPr>
-          <p:cNvPr id="8" name="Shape 6"/>
-          <p:cNvSpPr/>
-          <p:nvPr/>
-        </p:nvSpPr>
-        <p:spPr>
-          <a:xfrm>
-            <a:off x="6400800" y="1691640"/>
-            <a:ext cx="5120640" cy="3429000"/>
+              <a:rPr lang="en-US" sz="950" b="1" dirty="0">
+                <a:solidFill>
+                  <a:srgbClr val="009E73"/>
+                </a:solidFill>
+              </a:rPr>
+              <a:t>PASS 4/4  |  text/marks 2.2%  |  low-contrast share 47.9%</a:t>
+            </a:r>
+            <a:endParaRPr lang="en-US" sz="950" dirty="0"/>
+          </a:p>
+        </p:txBody>
+      </p:sp>
+      <p:sp>
+        <p:nvSpPr>
+          <p:cNvPr id="10" name="Shape 7"/>
+          <p:cNvSpPr/>
+          <p:nvPr/>
+        </p:nvSpPr>
+        <p:spPr>
+          <a:xfrm>
+            <a:off x="658368" y="2862072"/>
+            <a:ext cx="2971800" cy="960120"/>
           </a:xfrm>
           <a:prstGeom prst="rect">
             <a:avLst/>
           </a:prstGeom>
           <a:solidFill>
-            <a:srgbClr val="FBEAE7"/>
+            <a:srgbClr val="FFFFFF"/>
           </a:solidFill>
           <a:ln w="12700">
             <a:solidFill>
-              <a:srgbClr val="F1B5AA"/>
+              <a:srgbClr val="CED6E0"/>
             </a:solidFill>
             <a:prstDash val="solid"/>
           </a:ln>
         </p:spPr>
       </p:sp>
-      <p:sp>
-        <p:nvSpPr>
-          <p:cNvPr id="9" name="Text 7"/>
-          <p:cNvSpPr/>
-          <p:nvPr/>
-        </p:nvSpPr>
-        <p:spPr>
-          <a:xfrm>
-            <a:off x="6675120" y="1920240"/>
-            <a:ext cx="2103120" cy="274320"/>
-          </a:xfrm>
-          <a:prstGeom prst="rect">
-            <a:avLst/>
-          </a:prstGeom>
-          <a:noFill/>
-          <a:ln/>
-        </p:spPr>
-        <p:txBody>
-          <a:bodyPr wrap="square" lIns="0" tIns="0" rIns="0" bIns="0" rtlCol="0" anchor="ctr"/>
-          <a:lstStyle/>
-          <a:p>
-            <a:pPr indent="0" marL="0">
-              <a:buNone/>
-            </a:pPr>
-            <a:r>
-              <a:rPr lang="en-US" sz="1500" b="1" dirty="0">
-                <a:solidFill>
-                  <a:srgbClr val="DC3220"/>
-                </a:solidFill>
-              </a:rPr>
-              <a:t>bad_chart.json</a:t>
-            </a:r>
-            <a:endParaRPr lang="en-US" sz="1500" dirty="0"/>
-          </a:p>
-        </p:txBody>
-      </p:sp>
-      <p:sp>
-        <p:nvSpPr>
-          <p:cNvPr id="10" name="Text 8"/>
-          <p:cNvSpPr/>
-          <p:nvPr/>
-        </p:nvSpPr>
-        <p:spPr>
-          <a:xfrm>
-            <a:off x="6675120" y="2423160"/>
-            <a:ext cx="4343400" cy="1645920"/>
-          </a:xfrm>
-          <a:prstGeom prst="rect">
-            <a:avLst/>
-          </a:prstGeom>
-          <a:noFill/>
-          <a:ln/>
-        </p:spPr>
-        <p:txBody>
-          <a:bodyPr wrap="square" lIns="635" tIns="635" rIns="635" bIns="635" rtlCol="0" anchor="ctr">
+      <p:pic>
+        <p:nvPicPr>
+          <p:cNvPr id="11" name="Image 1" descr="examples/thesis_inaccurate_causes.png">    </p:cNvPr>
+          <p:cNvPicPr>
+            <a:picLocks noChangeAspect="1"/>
+          </p:cNvPicPr>
+          <p:nvPr/>
+        </p:nvPicPr>
+        <p:blipFill>
+          <a:blip r:embed="rId2"/>
+          <a:stretch>
+            <a:fillRect/>
+          </a:stretch>
+        </p:blipFill>
+        <p:spPr>
+          <a:xfrm>
+            <a:off x="749808" y="2935224"/>
+            <a:ext cx="2788920" cy="777240"/>
+          </a:xfrm>
+          <a:prstGeom prst="rect">
+            <a:avLst/>
+          </a:prstGeom>
+        </p:spPr>
+      </p:pic>
+      <p:sp>
+        <p:nvSpPr>
+          <p:cNvPr id="12" name="Text 8"/>
+          <p:cNvSpPr/>
+          <p:nvPr/>
+        </p:nvSpPr>
+        <p:spPr>
+          <a:xfrm>
+            <a:off x="3840480" y="2926080"/>
+            <a:ext cx="3566160" cy="228600"/>
+          </a:xfrm>
+          <a:prstGeom prst="rect">
+            <a:avLst/>
+          </a:prstGeom>
+          <a:noFill/>
+          <a:ln/>
+        </p:spPr>
+        <p:txBody>
+          <a:bodyPr wrap="square" lIns="0" tIns="0" rIns="0" bIns="0" rtlCol="0" anchor="ctr">
             <a:normAutofit/>
           </a:bodyPr>
           <a:lstStyle/>
@@ -4518,90 +4489,338 @@
               <a:buNone/>
             </a:pPr>
             <a:r>
-              <a:rPr lang="en-US" sz="1500" dirty="0">
+              <a:rPr lang="en-US" sz="1320" b="1" dirty="0">
                 <a:solidFill>
                   <a:srgbClr val="172033"/>
                 </a:solidFill>
               </a:rPr>
-              <a:t>Score: 0/4</a:t>
-            </a:r>
-            <a:endParaRPr lang="en-US" sz="1500" dirty="0"/>
-          </a:p>
-          <a:p>
-            <a:pPr indent="0" marL="0">
-              <a:buNone/>
-            </a:pPr>
-            <a:r>
-              <a:rPr lang="en-US" sz="1500" dirty="0">
+              <a:t>Thesis: Inaccurate Causes</a:t>
+            </a:r>
+            <a:endParaRPr lang="en-US" sz="1320" dirty="0"/>
+          </a:p>
+        </p:txBody>
+      </p:sp>
+      <p:sp>
+        <p:nvSpPr>
+          <p:cNvPr id="13" name="Shape 9"/>
+          <p:cNvSpPr/>
+          <p:nvPr/>
+        </p:nvSpPr>
+        <p:spPr>
+          <a:xfrm>
+            <a:off x="3840480" y="3291840"/>
+            <a:ext cx="4754880" cy="365760"/>
+          </a:xfrm>
+          <a:prstGeom prst="roundRect">
+            <a:avLst>
+              <a:gd name="adj" fmla="val 12500"/>
+            </a:avLst>
+          </a:prstGeom>
+          <a:solidFill>
+            <a:srgbClr val="EAF7F1"/>
+          </a:solidFill>
+          <a:ln w="12700">
+            <a:solidFill>
+              <a:srgbClr val="EAF7F1"/>
+            </a:solidFill>
+            <a:prstDash val="solid"/>
+          </a:ln>
+        </p:spPr>
+      </p:sp>
+      <p:sp>
+        <p:nvSpPr>
+          <p:cNvPr id="14" name="Text 10"/>
+          <p:cNvSpPr/>
+          <p:nvPr/>
+        </p:nvSpPr>
+        <p:spPr>
+          <a:xfrm>
+            <a:off x="3950208" y="3374136"/>
+            <a:ext cx="4535424" cy="164592"/>
+          </a:xfrm>
+          <a:prstGeom prst="rect">
+            <a:avLst/>
+          </a:prstGeom>
+          <a:noFill/>
+          <a:ln/>
+        </p:spPr>
+        <p:txBody>
+          <a:bodyPr wrap="square" lIns="0" tIns="0" rIns="0" bIns="0" rtlCol="0" anchor="ctr">
+            <a:normAutofit/>
+          </a:bodyPr>
+          <a:lstStyle/>
+          <a:p>
+            <a:pPr indent="0" marL="0">
+              <a:buNone/>
+            </a:pPr>
+            <a:r>
+              <a:rPr lang="en-US" sz="950" b="1" dirty="0">
+                <a:solidFill>
+                  <a:srgbClr val="009E73"/>
+                </a:solidFill>
+              </a:rPr>
+              <a:t>PASS 4/4  |  text/marks 5.7%  |  low-contrast share 56.4%</a:t>
+            </a:r>
+            <a:endParaRPr lang="en-US" sz="950" dirty="0"/>
+          </a:p>
+        </p:txBody>
+      </p:sp>
+      <p:sp>
+        <p:nvSpPr>
+          <p:cNvPr id="15" name="Shape 11"/>
+          <p:cNvSpPr/>
+          <p:nvPr/>
+        </p:nvSpPr>
+        <p:spPr>
+          <a:xfrm>
+            <a:off x="658368" y="4142232"/>
+            <a:ext cx="2971800" cy="960120"/>
+          </a:xfrm>
+          <a:prstGeom prst="rect">
+            <a:avLst/>
+          </a:prstGeom>
+          <a:solidFill>
+            <a:srgbClr val="FFFFFF"/>
+          </a:solidFill>
+          <a:ln w="12700">
+            <a:solidFill>
+              <a:srgbClr val="CED6E0"/>
+            </a:solidFill>
+            <a:prstDash val="solid"/>
+          </a:ln>
+        </p:spPr>
+      </p:sp>
+      <p:pic>
+        <p:nvPicPr>
+          <p:cNvPr id="16" name="Image 2" descr="examples/poster_emotions_table.png">    </p:cNvPr>
+          <p:cNvPicPr>
+            <a:picLocks noChangeAspect="1"/>
+          </p:cNvPicPr>
+          <p:nvPr/>
+        </p:nvPicPr>
+        <p:blipFill>
+          <a:blip r:embed="rId3"/>
+          <a:stretch>
+            <a:fillRect/>
+          </a:stretch>
+        </p:blipFill>
+        <p:spPr>
+          <a:xfrm>
+            <a:off x="749808" y="4215384"/>
+            <a:ext cx="2788920" cy="777240"/>
+          </a:xfrm>
+          <a:prstGeom prst="rect">
+            <a:avLst/>
+          </a:prstGeom>
+        </p:spPr>
+      </p:pic>
+      <p:sp>
+        <p:nvSpPr>
+          <p:cNvPr id="17" name="Text 12"/>
+          <p:cNvSpPr/>
+          <p:nvPr/>
+        </p:nvSpPr>
+        <p:spPr>
+          <a:xfrm>
+            <a:off x="3840480" y="4206240"/>
+            <a:ext cx="3566160" cy="228600"/>
+          </a:xfrm>
+          <a:prstGeom prst="rect">
+            <a:avLst/>
+          </a:prstGeom>
+          <a:noFill/>
+          <a:ln/>
+        </p:spPr>
+        <p:txBody>
+          <a:bodyPr wrap="square" lIns="0" tIns="0" rIns="0" bIns="0" rtlCol="0" anchor="ctr">
+            <a:normAutofit/>
+          </a:bodyPr>
+          <a:lstStyle/>
+          <a:p>
+            <a:pPr indent="0" marL="0">
+              <a:buNone/>
+            </a:pPr>
+            <a:r>
+              <a:rPr lang="en-US" sz="1320" b="1" dirty="0">
                 <a:solidFill>
                   <a:srgbClr val="172033"/>
                 </a:solidFill>
               </a:rPr>
-              <a:t>Overall: NEEDS WORK</a:t>
-            </a:r>
-            <a:endParaRPr lang="en-US" sz="1500" dirty="0"/>
-          </a:p>
-          <a:p>
-            <a:pPr indent="0" marL="0">
-              <a:buNone/>
-            </a:pPr>
-            <a:r>
-              <a:rPr lang="en-US" sz="1500" dirty="0">
+              <a:t>Poster: Emotions Table</a:t>
+            </a:r>
+            <a:endParaRPr lang="en-US" sz="1320" dirty="0"/>
+          </a:p>
+        </p:txBody>
+      </p:sp>
+      <p:sp>
+        <p:nvSpPr>
+          <p:cNvPr id="18" name="Shape 13"/>
+          <p:cNvSpPr/>
+          <p:nvPr/>
+        </p:nvSpPr>
+        <p:spPr>
+          <a:xfrm>
+            <a:off x="3840480" y="4572000"/>
+            <a:ext cx="4754880" cy="365760"/>
+          </a:xfrm>
+          <a:prstGeom prst="roundRect">
+            <a:avLst>
+              <a:gd name="adj" fmla="val 12500"/>
+            </a:avLst>
+          </a:prstGeom>
+          <a:solidFill>
+            <a:srgbClr val="EAF7F1"/>
+          </a:solidFill>
+          <a:ln w="12700">
+            <a:solidFill>
+              <a:srgbClr val="EAF7F1"/>
+            </a:solidFill>
+            <a:prstDash val="solid"/>
+          </a:ln>
+        </p:spPr>
+      </p:sp>
+      <p:sp>
+        <p:nvSpPr>
+          <p:cNvPr id="19" name="Text 14"/>
+          <p:cNvSpPr/>
+          <p:nvPr/>
+        </p:nvSpPr>
+        <p:spPr>
+          <a:xfrm>
+            <a:off x="3950208" y="4654296"/>
+            <a:ext cx="4535424" cy="164592"/>
+          </a:xfrm>
+          <a:prstGeom prst="rect">
+            <a:avLst/>
+          </a:prstGeom>
+          <a:noFill/>
+          <a:ln/>
+        </p:spPr>
+        <p:txBody>
+          <a:bodyPr wrap="square" lIns="0" tIns="0" rIns="0" bIns="0" rtlCol="0" anchor="ctr">
+            <a:normAutofit/>
+          </a:bodyPr>
+          <a:lstStyle/>
+          <a:p>
+            <a:pPr indent="0" marL="0">
+              <a:buNone/>
+            </a:pPr>
+            <a:r>
+              <a:rPr lang="en-US" sz="950" b="1" dirty="0">
+                <a:solidFill>
+                  <a:srgbClr val="009E73"/>
+                </a:solidFill>
+              </a:rPr>
+              <a:t>PASS 4/4  |  text/marks 45.5%  |  low-contrast share 38.0%</a:t>
+            </a:r>
+            <a:endParaRPr lang="en-US" sz="950" dirty="0"/>
+          </a:p>
+        </p:txBody>
+      </p:sp>
+      <p:sp>
+        <p:nvSpPr>
+          <p:cNvPr id="20" name="Shape 15"/>
+          <p:cNvSpPr/>
+          <p:nvPr/>
+        </p:nvSpPr>
+        <p:spPr>
+          <a:xfrm>
+            <a:off x="8915400" y="1691640"/>
+            <a:ext cx="2423160" cy="3063240"/>
+          </a:xfrm>
+          <a:prstGeom prst="rect">
+            <a:avLst/>
+          </a:prstGeom>
+          <a:solidFill>
+            <a:srgbClr val="F0F3F8"/>
+          </a:solidFill>
+          <a:ln w="12700">
+            <a:solidFill>
+              <a:srgbClr val="CED6E0"/>
+            </a:solidFill>
+            <a:prstDash val="solid"/>
+          </a:ln>
+        </p:spPr>
+      </p:sp>
+      <p:sp>
+        <p:nvSpPr>
+          <p:cNvPr id="21" name="Text 16"/>
+          <p:cNvSpPr/>
+          <p:nvPr/>
+        </p:nvSpPr>
+        <p:spPr>
+          <a:xfrm>
+            <a:off x="9162288" y="1956816"/>
+            <a:ext cx="1874520" cy="320040"/>
+          </a:xfrm>
+          <a:prstGeom prst="rect">
+            <a:avLst/>
+          </a:prstGeom>
+          <a:noFill/>
+          <a:ln/>
+        </p:spPr>
+        <p:txBody>
+          <a:bodyPr wrap="square" lIns="0" tIns="0" rIns="0" bIns="0" rtlCol="0" anchor="ctr">
+            <a:normAutofit/>
+          </a:bodyPr>
+          <a:lstStyle/>
+          <a:p>
+            <a:pPr indent="0" marL="0">
+              <a:buNone/>
+            </a:pPr>
+            <a:r>
+              <a:rPr lang="en-US" sz="1450" b="1" dirty="0">
+                <a:solidFill>
+                  <a:srgbClr val="005AB5"/>
+                </a:solidFill>
+              </a:rPr>
+              <a:t>Human review still matters</a:t>
+            </a:r>
+            <a:endParaRPr lang="en-US" sz="1450" dirty="0"/>
+          </a:p>
+        </p:txBody>
+      </p:sp>
+      <p:sp>
+        <p:nvSpPr>
+          <p:cNvPr id="22" name="Text 17"/>
+          <p:cNvSpPr/>
+          <p:nvPr/>
+        </p:nvSpPr>
+        <p:spPr>
+          <a:xfrm>
+            <a:off x="9162288" y="2542032"/>
+            <a:ext cx="1874520" cy="1417320"/>
+          </a:xfrm>
+          <a:prstGeom prst="rect">
+            <a:avLst/>
+          </a:prstGeom>
+          <a:noFill/>
+          <a:ln/>
+        </p:spPr>
+        <p:txBody>
+          <a:bodyPr wrap="square" lIns="0" tIns="0" rIns="0" bIns="0" rtlCol="0" anchor="ctr">
+            <a:normAutofit/>
+          </a:bodyPr>
+          <a:lstStyle/>
+          <a:p>
+            <a:pPr indent="0" marL="0">
+              <a:buNone/>
+            </a:pPr>
+            <a:r>
+              <a:rPr lang="en-US" sz="1250" dirty="0">
                 <a:solidFill>
                   <a:srgbClr val="172033"/>
                 </a:solidFill>
               </a:rPr>
-              <a:t>- low contrast</a:t>
-            </a:r>
-            <a:endParaRPr lang="en-US" sz="1500" dirty="0"/>
-          </a:p>
-          <a:p>
-            <a:pPr indent="0" marL="0">
-              <a:buNone/>
-            </a:pPr>
-            <a:r>
-              <a:rPr lang="en-US" sz="1500" dirty="0">
-                <a:solidFill>
-                  <a:srgbClr val="172033"/>
-                </a:solidFill>
-              </a:rPr>
-              <a:t>- 9 pt font</a:t>
-            </a:r>
-            <a:endParaRPr lang="en-US" sz="1500" dirty="0"/>
-          </a:p>
-          <a:p>
-            <a:pPr indent="0" marL="0">
-              <a:buNone/>
-            </a:pPr>
-            <a:r>
-              <a:rPr lang="en-US" sz="1500" dirty="0">
-                <a:solidFill>
-                  <a:srgbClr val="172033"/>
-                </a:solidFill>
-              </a:rPr>
-              <a:t>- missing labels</a:t>
-            </a:r>
-            <a:endParaRPr lang="en-US" sz="1500" dirty="0"/>
-          </a:p>
-          <a:p>
-            <a:pPr indent="0" marL="0">
-              <a:buNone/>
-            </a:pPr>
-            <a:r>
-              <a:rPr lang="en-US" sz="1500" dirty="0">
-                <a:solidFill>
-                  <a:srgbClr val="172033"/>
-                </a:solidFill>
-              </a:rPr>
-              <a:t>- short alt text</a:t>
-            </a:r>
-            <a:endParaRPr lang="en-US" sz="1500" dirty="0"/>
-          </a:p>
-        </p:txBody>
-      </p:sp>
-      <p:sp>
-        <p:nvSpPr>
-          <p:cNvPr id="11" name="Text 9"/>
+              <a:t>The pixel audit checks readability signals. A human should still improve semantic labels such as TRUE/FALSE legends and confirm the visual tells the intended story.</a:t>
+            </a:r>
+            <a:endParaRPr lang="en-US" sz="1250" dirty="0"/>
+          </a:p>
+        </p:txBody>
+      </p:sp>
+      <p:sp>
+        <p:nvSpPr>
+          <p:cNvPr id="23" name="Text 18"/>
           <p:cNvSpPr/>
           <p:nvPr/>
         </p:nvSpPr>
@@ -4637,7 +4856,7 @@
       </p:sp>
       <p:sp>
         <p:nvSpPr>
-          <p:cNvPr id="12" name="Shape 10"/>
+          <p:cNvPr id="24" name="Shape 19"/>
           <p:cNvSpPr/>
           <p:nvPr/>
         </p:nvSpPr>

</xml_diff>

<commit_message>
docs(presentation): enlarge text and use white backgrounds
</commit_message>
<xml_diff>
--- a/presentation/ChartAccess_Audit_SYSEN5493_Final.pptx
+++ b/presentation/ChartAccess_Audit_SYSEN5493_Final.pptx
@@ -1658,7 +1658,7 @@
     <p:bg>
       <p:bgPr>
         <a:solidFill>
-          <a:srgbClr val="101828"/>
+          <a:srgbClr val="FFFFFF"/>
         </a:solidFill>
       </p:bgPr>
     </p:bg>
@@ -1691,11 +1691,11 @@
             <a:avLst/>
           </a:prstGeom>
           <a:solidFill>
-            <a:srgbClr val="F0C808"/>
+            <a:srgbClr val="005AB5"/>
           </a:solidFill>
           <a:ln w="12700">
             <a:solidFill>
-              <a:srgbClr val="F0C808"/>
+              <a:srgbClr val="005AB5"/>
             </a:solidFill>
             <a:prstDash val="solid"/>
           </a:ln>
@@ -1726,9 +1726,9 @@
               <a:buNone/>
             </a:pPr>
             <a:r>
-              <a:rPr lang="en-US" sz="900" b="1" dirty="0">
-                <a:solidFill>
-                  <a:srgbClr val="D0D7E2"/>
+              <a:rPr lang="en-US" sz="1800" b="1" dirty="0">
+                <a:solidFill>
+                  <a:srgbClr val="5A667D"/>
                 </a:solidFill>
                 <a:latin typeface="Aptos" pitchFamily="34" charset="0"/>
                 <a:ea typeface="Aptos" pitchFamily="34" charset="-122"/>
@@ -1736,7 +1736,7 @@
               </a:rPr>
               <a:t>HOOK + PROBLEM</a:t>
             </a:r>
-            <a:endParaRPr lang="en-US" sz="900" dirty="0"/>
+            <a:endParaRPr lang="en-US" sz="1800" dirty="0"/>
           </a:p>
         </p:txBody>
       </p:sp>
@@ -1765,9 +1765,9 @@
               <a:buNone/>
             </a:pPr>
             <a:r>
-              <a:rPr lang="en-US" sz="3800" b="1" dirty="0">
-                <a:solidFill>
-                  <a:srgbClr val="FFFFFF"/>
+              <a:rPr lang="en-US" sz="4000" b="1" dirty="0">
+                <a:solidFill>
+                  <a:srgbClr val="172033"/>
                 </a:solidFill>
                 <a:latin typeface="Aptos Display" pitchFamily="34" charset="0"/>
                 <a:ea typeface="Aptos Display" pitchFamily="34" charset="-122"/>
@@ -1775,7 +1775,7 @@
               </a:rPr>
               <a:t>ChartAccess Audit</a:t>
             </a:r>
-            <a:endParaRPr lang="en-US" sz="3800" dirty="0"/>
+            <a:endParaRPr lang="en-US" sz="4000" dirty="0"/>
           </a:p>
         </p:txBody>
       </p:sp>
@@ -1806,14 +1806,14 @@
               <a:buNone/>
             </a:pPr>
             <a:r>
-              <a:rPr lang="en-US" sz="1800" dirty="0">
-                <a:solidFill>
-                  <a:srgbClr val="D0D7E2"/>
+              <a:rPr lang="en-US" sz="2200" dirty="0">
+                <a:solidFill>
+                  <a:srgbClr val="5A667D"/>
                 </a:solidFill>
               </a:rPr>
               <a:t>A lightweight AI-augmented workflow that verifies whether charts, tables, and presentation graphics are readable, inclusive, and presentation-ready.</a:t>
             </a:r>
-            <a:endParaRPr lang="en-US" sz="1800" dirty="0"/>
+            <a:endParaRPr lang="en-US" sz="2200" dirty="0"/>
           </a:p>
         </p:txBody>
       </p:sp>
@@ -1842,14 +1842,14 @@
               <a:buNone/>
             </a:pPr>
             <a:r>
-              <a:rPr lang="en-US" sz="2400" b="1" dirty="0">
-                <a:solidFill>
-                  <a:srgbClr val="F0C808"/>
+              <a:rPr lang="en-US" sz="2800" b="1" dirty="0">
+                <a:solidFill>
+                  <a:srgbClr val="005AB5"/>
                 </a:solidFill>
               </a:rPr>
               <a:t>4</a:t>
             </a:r>
-            <a:endParaRPr lang="en-US" sz="2400" dirty="0"/>
+            <a:endParaRPr lang="en-US" sz="2800" dirty="0"/>
           </a:p>
         </p:txBody>
       </p:sp>
@@ -1880,14 +1880,14 @@
               <a:buNone/>
             </a:pPr>
             <a:r>
-              <a:rPr lang="en-US" sz="950" dirty="0">
+              <a:rPr lang="en-US" sz="1800" dirty="0">
                 <a:solidFill>
                   <a:srgbClr val="5A667D"/>
                 </a:solidFill>
               </a:rPr>
               <a:t>accessibility requirements checked</a:t>
             </a:r>
-            <a:endParaRPr lang="en-US" sz="950" dirty="0"/>
+            <a:endParaRPr lang="en-US" sz="1800" dirty="0"/>
           </a:p>
         </p:txBody>
       </p:sp>
@@ -1916,14 +1916,14 @@
               <a:buNone/>
             </a:pPr>
             <a:r>
-              <a:rPr lang="en-US" sz="2400" b="1" dirty="0">
+              <a:rPr lang="en-US" sz="2800" b="1" dirty="0">
                 <a:solidFill>
                   <a:srgbClr val="009E73"/>
                 </a:solidFill>
               </a:rPr>
               <a:t>3</a:t>
             </a:r>
-            <a:endParaRPr lang="en-US" sz="2400" dirty="0"/>
+            <a:endParaRPr lang="en-US" sz="2800" dirty="0"/>
           </a:p>
         </p:txBody>
       </p:sp>
@@ -1954,14 +1954,14 @@
               <a:buNone/>
             </a:pPr>
             <a:r>
-              <a:rPr lang="en-US" sz="950" dirty="0">
+              <a:rPr lang="en-US" sz="1800" dirty="0">
                 <a:solidFill>
                   <a:srgbClr val="5A667D"/>
                 </a:solidFill>
               </a:rPr>
               <a:t>unit tests run in CI</a:t>
             </a:r>
-            <a:endParaRPr lang="en-US" sz="950" dirty="0"/>
+            <a:endParaRPr lang="en-US" sz="1800" dirty="0"/>
           </a:p>
         </p:txBody>
       </p:sp>
@@ -1990,14 +1990,14 @@
               <a:buNone/>
             </a:pPr>
             <a:r>
-              <a:rPr lang="en-US" sz="2400" b="1" dirty="0">
+              <a:rPr lang="en-US" sz="2800" b="1" dirty="0">
                 <a:solidFill>
                   <a:srgbClr val="9AC7FF"/>
                 </a:solidFill>
               </a:rPr>
               <a:t>10</a:t>
             </a:r>
-            <a:endParaRPr lang="en-US" sz="2400" dirty="0"/>
+            <a:endParaRPr lang="en-US" sz="2800" dirty="0"/>
           </a:p>
         </p:txBody>
       </p:sp>
@@ -2028,14 +2028,14 @@
               <a:buNone/>
             </a:pPr>
             <a:r>
-              <a:rPr lang="en-US" sz="950" dirty="0">
+              <a:rPr lang="en-US" sz="1800" dirty="0">
                 <a:solidFill>
                   <a:srgbClr val="5A667D"/>
                 </a:solidFill>
               </a:rPr>
               <a:t>minutes to explain the workflow</a:t>
             </a:r>
-            <a:endParaRPr lang="en-US" sz="950" dirty="0"/>
+            <a:endParaRPr lang="en-US" sz="1800" dirty="0"/>
           </a:p>
         </p:txBody>
       </p:sp>
@@ -2116,8 +2116,8 @@
         </p:nvSpPr>
         <p:spPr>
           <a:xfrm>
-            <a:off x="502920" y="6446520"/>
-            <a:ext cx="2926080" cy="182880"/>
+            <a:off x="502920" y="6263640"/>
+            <a:ext cx="4023360" cy="320040"/>
           </a:xfrm>
           <a:prstGeom prst="rect">
             <a:avLst/>
@@ -2133,14 +2133,14 @@
               <a:buNone/>
             </a:pPr>
             <a:r>
-              <a:rPr lang="en-US" sz="750" dirty="0">
-                <a:solidFill>
-                  <a:srgbClr val="9EA7B8"/>
+              <a:rPr lang="en-US" sz="1800" dirty="0">
+                <a:solidFill>
+                  <a:srgbClr val="5A667D"/>
                 </a:solidFill>
               </a:rPr>
               <a:t>SYSEN 5493 final project  /  1</a:t>
             </a:r>
-            <a:endParaRPr lang="en-US" sz="750" dirty="0"/>
+            <a:endParaRPr lang="en-US" sz="1800" dirty="0"/>
           </a:p>
         </p:txBody>
       </p:sp>
@@ -2161,7 +2161,7 @@
           <a:noFill/>
           <a:ln w="12700">
             <a:solidFill>
-              <a:srgbClr val="344054"/>
+              <a:srgbClr val="CED6E0"/>
             </a:solidFill>
             <a:prstDash val="solid"/>
           </a:ln>
@@ -2181,7 +2181,7 @@
     <p:bg>
       <p:bgPr>
         <a:solidFill>
-          <a:srgbClr val="101828"/>
+          <a:srgbClr val="FFFFFF"/>
         </a:solidFill>
       </p:bgPr>
     </p:bg>
@@ -2214,11 +2214,11 @@
             <a:avLst/>
           </a:prstGeom>
           <a:solidFill>
-            <a:srgbClr val="F0C808"/>
+            <a:srgbClr val="005AB5"/>
           </a:solidFill>
           <a:ln w="12700">
             <a:solidFill>
-              <a:srgbClr val="F0C808"/>
+              <a:srgbClr val="005AB5"/>
             </a:solidFill>
             <a:prstDash val="solid"/>
           </a:ln>
@@ -2249,9 +2249,9 @@
               <a:buNone/>
             </a:pPr>
             <a:r>
-              <a:rPr lang="en-US" sz="900" b="1" dirty="0">
-                <a:solidFill>
-                  <a:srgbClr val="D0D7E2"/>
+              <a:rPr lang="en-US" sz="1800" b="1" dirty="0">
+                <a:solidFill>
+                  <a:srgbClr val="5A667D"/>
                 </a:solidFill>
                 <a:latin typeface="Aptos" pitchFamily="34" charset="0"/>
                 <a:ea typeface="Aptos" pitchFamily="34" charset="-122"/>
@@ -2259,7 +2259,7 @@
               </a:rPr>
               <a:t>TAKEAWAYS + Q&amp;A</a:t>
             </a:r>
-            <a:endParaRPr lang="en-US" sz="900" dirty="0"/>
+            <a:endParaRPr lang="en-US" sz="1800" dirty="0"/>
           </a:p>
         </p:txBody>
       </p:sp>
@@ -2290,9 +2290,9 @@
               <a:buNone/>
             </a:pPr>
             <a:r>
-              <a:rPr lang="en-US" sz="2600" b="1" dirty="0">
-                <a:solidFill>
-                  <a:srgbClr val="FFFFFF"/>
+              <a:rPr lang="en-US" sz="3000" b="1" dirty="0">
+                <a:solidFill>
+                  <a:srgbClr val="172033"/>
                 </a:solidFill>
                 <a:latin typeface="Aptos Display" pitchFamily="34" charset="0"/>
                 <a:ea typeface="Aptos Display" pitchFamily="34" charset="-122"/>
@@ -2300,7 +2300,7 @@
               </a:rPr>
               <a:t>A small checker can make inclusive visual design part of the workflow.</a:t>
             </a:r>
-            <a:endParaRPr lang="en-US" sz="2600" dirty="0"/>
+            <a:endParaRPr lang="en-US" sz="3000" dirty="0"/>
           </a:p>
         </p:txBody>
       </p:sp>
@@ -2332,14 +2332,14 @@
               <a:buChar char="•"/>
             </a:pPr>
             <a:r>
-              <a:rPr lang="en-US" sz="1350" dirty="0">
-                <a:solidFill>
-                  <a:srgbClr val="E4E7EC"/>
+              <a:rPr lang="en-US" sz="1800" dirty="0">
+                <a:solidFill>
+                  <a:srgbClr val="172033"/>
                 </a:solidFill>
               </a:rPr>
               <a:t>The project is cloneable, testable, CI-ready, and now supports PNG upload.</a:t>
             </a:r>
-            <a:endParaRPr lang="en-US" sz="1350" dirty="0"/>
+            <a:endParaRPr lang="en-US" sz="1800" dirty="0"/>
           </a:p>
           <a:p>
             <a:pPr marL="152400" indent="-152400">
@@ -2347,14 +2347,14 @@
               <a:buChar char="•"/>
             </a:pPr>
             <a:r>
-              <a:rPr lang="en-US" sz="1350" dirty="0">
-                <a:solidFill>
-                  <a:srgbClr val="E4E7EC"/>
+              <a:rPr lang="en-US" sz="1800" dirty="0">
+                <a:solidFill>
+                  <a:srgbClr val="172033"/>
                 </a:solidFill>
               </a:rPr>
               <a:t>The Git history demonstrates branching, merging, conventional commits, and conflict resolution.</a:t>
             </a:r>
-            <a:endParaRPr lang="en-US" sz="1350" dirty="0"/>
+            <a:endParaRPr lang="en-US" sz="1800" dirty="0"/>
           </a:p>
           <a:p>
             <a:pPr marL="152400" indent="-152400">
@@ -2362,14 +2362,14 @@
               <a:buChar char="•"/>
             </a:pPr>
             <a:r>
-              <a:rPr lang="en-US" sz="1350" dirty="0">
-                <a:solidFill>
-                  <a:srgbClr val="E4E7EC"/>
+              <a:rPr lang="en-US" sz="1800" dirty="0">
+                <a:solidFill>
+                  <a:srgbClr val="172033"/>
                 </a:solidFill>
               </a:rPr>
               <a:t>AI accelerated planning and review, but human judgment set the requirements.</a:t>
             </a:r>
-            <a:endParaRPr lang="en-US" sz="1350" dirty="0"/>
+            <a:endParaRPr lang="en-US" sz="1800" dirty="0"/>
           </a:p>
         </p:txBody>
       </p:sp>
@@ -2382,7 +2382,7 @@
         <p:spPr>
           <a:xfrm>
             <a:off x="7315200" y="1828800"/>
-            <a:ext cx="2743200" cy="256032"/>
+            <a:ext cx="2926080" cy="365760"/>
           </a:xfrm>
           <a:prstGeom prst="rect">
             <a:avLst/>
@@ -2398,14 +2398,14 @@
               <a:buNone/>
             </a:pPr>
             <a:r>
-              <a:rPr lang="en-US" sz="1200" b="1" dirty="0">
-                <a:solidFill>
-                  <a:srgbClr val="F0C808"/>
+              <a:rPr lang="en-US" sz="1800" b="1" dirty="0">
+                <a:solidFill>
+                  <a:srgbClr val="005AB5"/>
                 </a:solidFill>
               </a:rPr>
               <a:t>Question to discuss</a:t>
             </a:r>
-            <a:endParaRPr lang="en-US" sz="1200" dirty="0"/>
+            <a:endParaRPr lang="en-US" sz="1800" dirty="0"/>
           </a:p>
         </p:txBody>
       </p:sp>
@@ -2438,7 +2438,7 @@
             <a:r>
               <a:rPr lang="en-US" sz="2000" b="1" dirty="0">
                 <a:solidFill>
-                  <a:srgbClr val="FFFFFF"/>
+                  <a:srgbClr val="172033"/>
                 </a:solidFill>
               </a:rPr>
               <a:t>Which inclusive-design checks should become automated gates before reports, posters, or slides are shared?</a:t>
@@ -2455,8 +2455,8 @@
         </p:nvSpPr>
         <p:spPr>
           <a:xfrm>
-            <a:off x="502920" y="6446520"/>
-            <a:ext cx="2926080" cy="182880"/>
+            <a:off x="502920" y="6263640"/>
+            <a:ext cx="4023360" cy="320040"/>
           </a:xfrm>
           <a:prstGeom prst="rect">
             <a:avLst/>
@@ -2472,14 +2472,14 @@
               <a:buNone/>
             </a:pPr>
             <a:r>
-              <a:rPr lang="en-US" sz="750" dirty="0">
-                <a:solidFill>
-                  <a:srgbClr val="9EA7B8"/>
+              <a:rPr lang="en-US" sz="1800" dirty="0">
+                <a:solidFill>
+                  <a:srgbClr val="5A667D"/>
                 </a:solidFill>
               </a:rPr>
               <a:t>SYSEN 5493 final project  /  10</a:t>
             </a:r>
-            <a:endParaRPr lang="en-US" sz="750" dirty="0"/>
+            <a:endParaRPr lang="en-US" sz="1800" dirty="0"/>
           </a:p>
         </p:txBody>
       </p:sp>
@@ -2500,7 +2500,7 @@
           <a:noFill/>
           <a:ln w="12700">
             <a:solidFill>
-              <a:srgbClr val="344054"/>
+              <a:srgbClr val="CED6E0"/>
             </a:solidFill>
             <a:prstDash val="solid"/>
           </a:ln>
@@ -2520,7 +2520,7 @@
     <p:bg>
       <p:bgPr>
         <a:solidFill>
-          <a:srgbClr val="F7F5EF"/>
+          <a:srgbClr val="FFFFFF"/>
         </a:solidFill>
       </p:bgPr>
     </p:bg>
@@ -2588,7 +2588,7 @@
               <a:buNone/>
             </a:pPr>
             <a:r>
-              <a:rPr lang="en-US" sz="900" b="1" dirty="0">
+              <a:rPr lang="en-US" sz="1800" b="1" dirty="0">
                 <a:solidFill>
                   <a:srgbClr val="5A667D"/>
                 </a:solidFill>
@@ -2598,7 +2598,7 @@
               </a:rPr>
               <a:t>STAKEHOLDER NEED</a:t>
             </a:r>
-            <a:endParaRPr lang="en-US" sz="900" dirty="0"/>
+            <a:endParaRPr lang="en-US" sz="1800" dirty="0"/>
           </a:p>
         </p:txBody>
       </p:sp>
@@ -2629,7 +2629,7 @@
               <a:buNone/>
             </a:pPr>
             <a:r>
-              <a:rPr lang="en-US" sz="2600" b="1" dirty="0">
+              <a:rPr lang="en-US" sz="3000" b="1" dirty="0">
                 <a:solidFill>
                   <a:srgbClr val="172033"/>
                 </a:solidFill>
@@ -2639,7 +2639,7 @@
               </a:rPr>
               <a:t>Unreadable visuals create hidden system failures.</a:t>
             </a:r>
-            <a:endParaRPr lang="en-US" sz="2600" dirty="0"/>
+            <a:endParaRPr lang="en-US" sz="3000" dirty="0"/>
           </a:p>
         </p:txBody>
       </p:sp>
@@ -2671,14 +2671,14 @@
               <a:buChar char="•"/>
             </a:pPr>
             <a:r>
-              <a:rPr lang="en-US" sz="1350" dirty="0">
+              <a:rPr lang="en-US" sz="1800" dirty="0">
                 <a:solidFill>
                   <a:srgbClr val="172033"/>
                 </a:solidFill>
               </a:rPr>
               <a:t>Students and engineers often choose colors and fonts by taste, not verifiable requirements.</a:t>
             </a:r>
-            <a:endParaRPr lang="en-US" sz="1350" dirty="0"/>
+            <a:endParaRPr lang="en-US" sz="1800" dirty="0"/>
           </a:p>
           <a:p>
             <a:pPr marL="152400" indent="-152400">
@@ -2686,14 +2686,14 @@
               <a:buChar char="•"/>
             </a:pPr>
             <a:r>
-              <a:rPr lang="en-US" sz="1350" dirty="0">
+              <a:rPr lang="en-US" sz="1800" dirty="0">
                 <a:solidFill>
                   <a:srgbClr val="172033"/>
                 </a:solidFill>
               </a:rPr>
               <a:t>Low contrast, tiny type, and missing labels exclude users and weaken decisions.</a:t>
             </a:r>
-            <a:endParaRPr lang="en-US" sz="1350" dirty="0"/>
+            <a:endParaRPr lang="en-US" sz="1800" dirty="0"/>
           </a:p>
           <a:p>
             <a:pPr marL="152400" indent="-152400">
@@ -2701,14 +2701,14 @@
               <a:buChar char="•"/>
             </a:pPr>
             <a:r>
-              <a:rPr lang="en-US" sz="1350" dirty="0">
+              <a:rPr lang="en-US" sz="1800" dirty="0">
                 <a:solidFill>
                   <a:srgbClr val="172033"/>
                 </a:solidFill>
               </a:rPr>
               <a:t>The project converts inclusive design advice into checks that can run before a visual is shared.</a:t>
             </a:r>
-            <a:endParaRPr lang="en-US" sz="1350" dirty="0"/>
+            <a:endParaRPr lang="en-US" sz="1800" dirty="0"/>
           </a:p>
         </p:txBody>
       </p:sp>
@@ -2746,7 +2746,7 @@
         <p:spPr>
           <a:xfrm>
             <a:off x="6629400" y="1783080"/>
-            <a:ext cx="1828800" cy="228600"/>
+            <a:ext cx="2286000" cy="347472"/>
           </a:xfrm>
           <a:prstGeom prst="rect">
             <a:avLst/>
@@ -2762,14 +2762,14 @@
               <a:buNone/>
             </a:pPr>
             <a:r>
-              <a:rPr lang="en-US" sz="1100" b="1" dirty="0">
+              <a:rPr lang="en-US" sz="1800" b="1" dirty="0">
                 <a:solidFill>
                   <a:srgbClr val="DC3220"/>
                 </a:solidFill>
               </a:rPr>
               <a:t>Bad chart spec</a:t>
             </a:r>
-            <a:endParaRPr lang="en-US" sz="1100" dirty="0"/>
+            <a:endParaRPr lang="en-US" sz="1800" dirty="0"/>
           </a:p>
         </p:txBody>
       </p:sp>
@@ -2800,7 +2800,7 @@
               <a:buNone/>
             </a:pPr>
             <a:r>
-              <a:rPr lang="en-US" sz="1400" dirty="0">
+              <a:rPr lang="en-US" sz="1800" dirty="0">
                 <a:solidFill>
                   <a:srgbClr val="172033"/>
                 </a:solidFill>
@@ -2810,14 +2810,14 @@
               </a:rPr>
               <a:t>#ffff99 on white</a:t>
             </a:r>
-            <a:endParaRPr lang="en-US" sz="1400" dirty="0"/>
-          </a:p>
-          <a:p>
-            <a:pPr indent="0" marL="0">
-              <a:buNone/>
-            </a:pPr>
-            <a:r>
-              <a:rPr lang="en-US" sz="1400" dirty="0">
+            <a:endParaRPr lang="en-US" sz="1800" dirty="0"/>
+          </a:p>
+          <a:p>
+            <a:pPr indent="0" marL="0">
+              <a:buNone/>
+            </a:pPr>
+            <a:r>
+              <a:rPr lang="en-US" sz="1800" dirty="0">
                 <a:solidFill>
                   <a:srgbClr val="172033"/>
                 </a:solidFill>
@@ -2827,14 +2827,14 @@
               </a:rPr>
               <a:t>9 pt font</a:t>
             </a:r>
-            <a:endParaRPr lang="en-US" sz="1400" dirty="0"/>
-          </a:p>
-          <a:p>
-            <a:pPr indent="0" marL="0">
-              <a:buNone/>
-            </a:pPr>
-            <a:r>
-              <a:rPr lang="en-US" sz="1400" dirty="0">
+            <a:endParaRPr lang="en-US" sz="1800" dirty="0"/>
+          </a:p>
+          <a:p>
+            <a:pPr indent="0" marL="0">
+              <a:buNone/>
+            </a:pPr>
+            <a:r>
+              <a:rPr lang="en-US" sz="1800" dirty="0">
                 <a:solidFill>
                   <a:srgbClr val="172033"/>
                 </a:solidFill>
@@ -2844,14 +2844,14 @@
               </a:rPr>
               <a:t>missing axis labels</a:t>
             </a:r>
-            <a:endParaRPr lang="en-US" sz="1400" dirty="0"/>
-          </a:p>
-          <a:p>
-            <a:pPr indent="0" marL="0">
-              <a:buNone/>
-            </a:pPr>
-            <a:r>
-              <a:rPr lang="en-US" sz="1400" dirty="0">
+            <a:endParaRPr lang="en-US" sz="1800" dirty="0"/>
+          </a:p>
+          <a:p>
+            <a:pPr indent="0" marL="0">
+              <a:buNone/>
+            </a:pPr>
+            <a:r>
+              <a:rPr lang="en-US" sz="1800" dirty="0">
                 <a:solidFill>
                   <a:srgbClr val="172033"/>
                 </a:solidFill>
@@ -2861,7 +2861,7 @@
               </a:rPr>
               <a:t>"Chart of results."</a:t>
             </a:r>
-            <a:endParaRPr lang="en-US" sz="1400" dirty="0"/>
+            <a:endParaRPr lang="en-US" sz="1800" dirty="0"/>
           </a:p>
         </p:txBody>
       </p:sp>
@@ -2919,14 +2919,14 @@
               <a:buNone/>
             </a:pPr>
             <a:r>
-              <a:rPr lang="en-US" sz="950" b="1" dirty="0">
+              <a:rPr lang="en-US" sz="1800" b="1" dirty="0">
                 <a:solidFill>
                   <a:srgbClr val="DC3220"/>
                 </a:solidFill>
               </a:rPr>
               <a:t>FAILS 4 / 4 CHECKS</a:t>
             </a:r>
-            <a:endParaRPr lang="en-US" sz="950" dirty="0"/>
+            <a:endParaRPr lang="en-US" sz="1800" dirty="0"/>
           </a:p>
         </p:txBody>
       </p:sp>
@@ -2938,8 +2938,8 @@
         </p:nvSpPr>
         <p:spPr>
           <a:xfrm>
-            <a:off x="502920" y="6446520"/>
-            <a:ext cx="2926080" cy="182880"/>
+            <a:off x="502920" y="6263640"/>
+            <a:ext cx="4023360" cy="320040"/>
           </a:xfrm>
           <a:prstGeom prst="rect">
             <a:avLst/>
@@ -2955,14 +2955,14 @@
               <a:buNone/>
             </a:pPr>
             <a:r>
-              <a:rPr lang="en-US" sz="750" dirty="0">
+              <a:rPr lang="en-US" sz="1800" dirty="0">
                 <a:solidFill>
                   <a:srgbClr val="5A667D"/>
                 </a:solidFill>
               </a:rPr>
               <a:t>SYSEN 5493 final project  /  2</a:t>
             </a:r>
-            <a:endParaRPr lang="en-US" sz="750" dirty="0"/>
+            <a:endParaRPr lang="en-US" sz="1800" dirty="0"/>
           </a:p>
         </p:txBody>
       </p:sp>
@@ -3003,7 +3003,7 @@
     <p:bg>
       <p:bgPr>
         <a:solidFill>
-          <a:srgbClr val="F7F5EF"/>
+          <a:srgbClr val="FFFFFF"/>
         </a:solidFill>
       </p:bgPr>
     </p:bg>
@@ -3071,7 +3071,7 @@
               <a:buNone/>
             </a:pPr>
             <a:r>
-              <a:rPr lang="en-US" sz="900" b="1" dirty="0">
+              <a:rPr lang="en-US" sz="1800" b="1" dirty="0">
                 <a:solidFill>
                   <a:srgbClr val="5A667D"/>
                 </a:solidFill>
@@ -3081,7 +3081,7 @@
               </a:rPr>
               <a:t>APPROACH</a:t>
             </a:r>
-            <a:endParaRPr lang="en-US" sz="900" dirty="0"/>
+            <a:endParaRPr lang="en-US" sz="1800" dirty="0"/>
           </a:p>
         </p:txBody>
       </p:sp>
@@ -3112,7 +3112,7 @@
               <a:buNone/>
             </a:pPr>
             <a:r>
-              <a:rPr lang="en-US" sz="2600" b="1" dirty="0">
+              <a:rPr lang="en-US" sz="3000" b="1" dirty="0">
                 <a:solidFill>
                   <a:srgbClr val="172033"/>
                 </a:solidFill>
@@ -3122,7 +3122,7 @@
               </a:rPr>
               <a:t>The workflow turns inclusive design guidance into verification logic.</a:t>
             </a:r>
-            <a:endParaRPr lang="en-US" sz="2600" dirty="0"/>
+            <a:endParaRPr lang="en-US" sz="3000" dirty="0"/>
           </a:p>
         </p:txBody>
       </p:sp>
@@ -3159,44 +3159,8 @@
         </p:nvSpPr>
         <p:spPr>
           <a:xfrm>
-            <a:off x="978408" y="2103120"/>
-            <a:ext cx="2514600" cy="274320"/>
-          </a:xfrm>
-          <a:prstGeom prst="rect">
-            <a:avLst/>
-          </a:prstGeom>
-          <a:noFill/>
-          <a:ln/>
-        </p:spPr>
-        <p:txBody>
-          <a:bodyPr wrap="square" lIns="0" tIns="0" rIns="0" bIns="0" rtlCol="0" anchor="ctr"/>
-          <a:lstStyle/>
-          <a:p>
-            <a:pPr indent="0" marL="0">
-              <a:buNone/>
-            </a:pPr>
-            <a:r>
-              <a:rPr lang="en-US" sz="1700" b="1" dirty="0">
-                <a:solidFill>
-                  <a:srgbClr val="005AB5"/>
-                </a:solidFill>
-              </a:rPr>
-              <a:t>Visual input</a:t>
-            </a:r>
-            <a:endParaRPr lang="en-US" sz="1700" dirty="0"/>
-          </a:p>
-        </p:txBody>
-      </p:sp>
-      <p:sp>
-        <p:nvSpPr>
-          <p:cNvPr id="7" name="Text 5"/>
-          <p:cNvSpPr/>
-          <p:nvPr/>
-        </p:nvSpPr>
-        <p:spPr>
-          <a:xfrm>
-            <a:off x="978408" y="2651760"/>
-            <a:ext cx="2514600" cy="594360"/>
+            <a:off x="978408" y="2057400"/>
+            <a:ext cx="2514600" cy="411480"/>
           </a:xfrm>
           <a:prstGeom prst="rect">
             <a:avLst/>
@@ -3214,14 +3178,52 @@
               <a:buNone/>
             </a:pPr>
             <a:r>
-              <a:rPr lang="en-US" sz="1200" dirty="0">
+              <a:rPr lang="en-US" sz="1800" b="1" dirty="0">
+                <a:solidFill>
+                  <a:srgbClr val="005AB5"/>
+                </a:solidFill>
+              </a:rPr>
+              <a:t>Visual input</a:t>
+            </a:r>
+            <a:endParaRPr lang="en-US" sz="1800" dirty="0"/>
+          </a:p>
+        </p:txBody>
+      </p:sp>
+      <p:sp>
+        <p:nvSpPr>
+          <p:cNvPr id="7" name="Text 5"/>
+          <p:cNvSpPr/>
+          <p:nvPr/>
+        </p:nvSpPr>
+        <p:spPr>
+          <a:xfrm>
+            <a:off x="978408" y="2651760"/>
+            <a:ext cx="2514600" cy="777240"/>
+          </a:xfrm>
+          <a:prstGeom prst="rect">
+            <a:avLst/>
+          </a:prstGeom>
+          <a:noFill/>
+          <a:ln/>
+        </p:spPr>
+        <p:txBody>
+          <a:bodyPr wrap="square" lIns="0" tIns="0" rIns="0" bIns="0" rtlCol="0" anchor="ctr">
+            <a:normAutofit/>
+          </a:bodyPr>
+          <a:lstStyle/>
+          <a:p>
+            <a:pPr indent="0" marL="0">
+              <a:buNone/>
+            </a:pPr>
+            <a:r>
+              <a:rPr lang="en-US" sz="1800" dirty="0">
                 <a:solidFill>
                   <a:srgbClr val="172033"/>
                 </a:solidFill>
               </a:rPr>
               <a:t>JSON metadata or uploaded PNG image</a:t>
             </a:r>
-            <a:endParaRPr lang="en-US" sz="1200" dirty="0"/>
+            <a:endParaRPr lang="en-US" sz="1800" dirty="0"/>
           </a:p>
         </p:txBody>
       </p:sp>
@@ -3283,44 +3285,8 @@
         </p:nvSpPr>
         <p:spPr>
           <a:xfrm>
-            <a:off x="4681728" y="2103120"/>
-            <a:ext cx="2514600" cy="274320"/>
-          </a:xfrm>
-          <a:prstGeom prst="rect">
-            <a:avLst/>
-          </a:prstGeom>
-          <a:noFill/>
-          <a:ln/>
-        </p:spPr>
-        <p:txBody>
-          <a:bodyPr wrap="square" lIns="0" tIns="0" rIns="0" bIns="0" rtlCol="0" anchor="ctr"/>
-          <a:lstStyle/>
-          <a:p>
-            <a:pPr indent="0" marL="0">
-              <a:buNone/>
-            </a:pPr>
-            <a:r>
-              <a:rPr lang="en-US" sz="1700" b="1" dirty="0">
-                <a:solidFill>
-                  <a:srgbClr val="172033"/>
-                </a:solidFill>
-              </a:rPr>
-              <a:t>Audit engine</a:t>
-            </a:r>
-            <a:endParaRPr lang="en-US" sz="1700" dirty="0"/>
-          </a:p>
-        </p:txBody>
-      </p:sp>
-      <p:sp>
-        <p:nvSpPr>
-          <p:cNvPr id="11" name="Text 9"/>
-          <p:cNvSpPr/>
-          <p:nvPr/>
-        </p:nvSpPr>
-        <p:spPr>
-          <a:xfrm>
-            <a:off x="4681728" y="2651760"/>
-            <a:ext cx="2514600" cy="594360"/>
+            <a:off x="4681728" y="2057400"/>
+            <a:ext cx="2514600" cy="411480"/>
           </a:xfrm>
           <a:prstGeom prst="rect">
             <a:avLst/>
@@ -3338,14 +3304,52 @@
               <a:buNone/>
             </a:pPr>
             <a:r>
-              <a:rPr lang="en-US" sz="1200" dirty="0">
+              <a:rPr lang="en-US" sz="1800" b="1" dirty="0">
                 <a:solidFill>
                   <a:srgbClr val="172033"/>
                 </a:solidFill>
               </a:rPr>
+              <a:t>Audit engine</a:t>
+            </a:r>
+            <a:endParaRPr lang="en-US" sz="1800" dirty="0"/>
+          </a:p>
+        </p:txBody>
+      </p:sp>
+      <p:sp>
+        <p:nvSpPr>
+          <p:cNvPr id="11" name="Text 9"/>
+          <p:cNvSpPr/>
+          <p:nvPr/>
+        </p:nvSpPr>
+        <p:spPr>
+          <a:xfrm>
+            <a:off x="4681728" y="2651760"/>
+            <a:ext cx="2514600" cy="777240"/>
+          </a:xfrm>
+          <a:prstGeom prst="rect">
+            <a:avLst/>
+          </a:prstGeom>
+          <a:noFill/>
+          <a:ln/>
+        </p:spPr>
+        <p:txBody>
+          <a:bodyPr wrap="square" lIns="0" tIns="0" rIns="0" bIns="0" rtlCol="0" anchor="ctr">
+            <a:normAutofit/>
+          </a:bodyPr>
+          <a:lstStyle/>
+          <a:p>
+            <a:pPr indent="0" marL="0">
+              <a:buNone/>
+            </a:pPr>
+            <a:r>
+              <a:rPr lang="en-US" sz="1800" dirty="0">
+                <a:solidFill>
+                  <a:srgbClr val="172033"/>
+                </a:solidFill>
+              </a:rPr>
               <a:t>contrast, readability, color usability, context</a:t>
             </a:r>
-            <a:endParaRPr lang="en-US" sz="1200" dirty="0"/>
+            <a:endParaRPr lang="en-US" sz="1800" dirty="0"/>
           </a:p>
         </p:txBody>
       </p:sp>
@@ -3407,44 +3411,8 @@
         </p:nvSpPr>
         <p:spPr>
           <a:xfrm>
-            <a:off x="8385048" y="2103120"/>
-            <a:ext cx="2514600" cy="274320"/>
-          </a:xfrm>
-          <a:prstGeom prst="rect">
-            <a:avLst/>
-          </a:prstGeom>
-          <a:noFill/>
-          <a:ln/>
-        </p:spPr>
-        <p:txBody>
-          <a:bodyPr wrap="square" lIns="0" tIns="0" rIns="0" bIns="0" rtlCol="0" anchor="ctr"/>
-          <a:lstStyle/>
-          <a:p>
-            <a:pPr indent="0" marL="0">
-              <a:buNone/>
-            </a:pPr>
-            <a:r>
-              <a:rPr lang="en-US" sz="1700" b="1" dirty="0">
-                <a:solidFill>
-                  <a:srgbClr val="009E73"/>
-                </a:solidFill>
-              </a:rPr>
-              <a:t>Report + tests</a:t>
-            </a:r>
-            <a:endParaRPr lang="en-US" sz="1700" dirty="0"/>
-          </a:p>
-        </p:txBody>
-      </p:sp>
-      <p:sp>
-        <p:nvSpPr>
-          <p:cNvPr id="15" name="Text 13"/>
-          <p:cNvSpPr/>
-          <p:nvPr/>
-        </p:nvSpPr>
-        <p:spPr>
-          <a:xfrm>
-            <a:off x="8385048" y="2651760"/>
-            <a:ext cx="2514600" cy="594360"/>
+            <a:off x="8385048" y="2057400"/>
+            <a:ext cx="2514600" cy="411480"/>
           </a:xfrm>
           <a:prstGeom prst="rect">
             <a:avLst/>
@@ -3462,14 +3430,52 @@
               <a:buNone/>
             </a:pPr>
             <a:r>
-              <a:rPr lang="en-US" sz="1200" dirty="0">
+              <a:rPr lang="en-US" sz="1800" b="1" dirty="0">
+                <a:solidFill>
+                  <a:srgbClr val="009E73"/>
+                </a:solidFill>
+              </a:rPr>
+              <a:t>Report + tests</a:t>
+            </a:r>
+            <a:endParaRPr lang="en-US" sz="1800" dirty="0"/>
+          </a:p>
+        </p:txBody>
+      </p:sp>
+      <p:sp>
+        <p:nvSpPr>
+          <p:cNvPr id="15" name="Text 13"/>
+          <p:cNvSpPr/>
+          <p:nvPr/>
+        </p:nvSpPr>
+        <p:spPr>
+          <a:xfrm>
+            <a:off x="8385048" y="2651760"/>
+            <a:ext cx="2514600" cy="777240"/>
+          </a:xfrm>
+          <a:prstGeom prst="rect">
+            <a:avLst/>
+          </a:prstGeom>
+          <a:noFill/>
+          <a:ln/>
+        </p:spPr>
+        <p:txBody>
+          <a:bodyPr wrap="square" lIns="0" tIns="0" rIns="0" bIns="0" rtlCol="0" anchor="ctr">
+            <a:normAutofit/>
+          </a:bodyPr>
+          <a:lstStyle/>
+          <a:p>
+            <a:pPr indent="0" marL="0">
+              <a:buNone/>
+            </a:pPr>
+            <a:r>
+              <a:rPr lang="en-US" sz="1800" dirty="0">
                 <a:solidFill>
                   <a:srgbClr val="172033"/>
                 </a:solidFill>
               </a:rPr>
               <a:t>PASS/FAIL output, unit tests, CI gate</a:t>
             </a:r>
-            <a:endParaRPr lang="en-US" sz="1200" dirty="0"/>
+            <a:endParaRPr lang="en-US" sz="1800" dirty="0"/>
           </a:p>
         </p:txBody>
       </p:sp>
@@ -3481,8 +3487,8 @@
         </p:nvSpPr>
         <p:spPr>
           <a:xfrm>
-            <a:off x="502920" y="6446520"/>
-            <a:ext cx="2926080" cy="182880"/>
+            <a:off x="502920" y="6263640"/>
+            <a:ext cx="4023360" cy="320040"/>
           </a:xfrm>
           <a:prstGeom prst="rect">
             <a:avLst/>
@@ -3498,14 +3504,14 @@
               <a:buNone/>
             </a:pPr>
             <a:r>
-              <a:rPr lang="en-US" sz="750" dirty="0">
+              <a:rPr lang="en-US" sz="1800" dirty="0">
                 <a:solidFill>
                   <a:srgbClr val="5A667D"/>
                 </a:solidFill>
               </a:rPr>
               <a:t>SYSEN 5493 final project  /  3</a:t>
             </a:r>
-            <a:endParaRPr lang="en-US" sz="750" dirty="0"/>
+            <a:endParaRPr lang="en-US" sz="1800" dirty="0"/>
           </a:p>
         </p:txBody>
       </p:sp>
@@ -3546,7 +3552,7 @@
     <p:bg>
       <p:bgPr>
         <a:solidFill>
-          <a:srgbClr val="F7F5EF"/>
+          <a:srgbClr val="FFFFFF"/>
         </a:solidFill>
       </p:bgPr>
     </p:bg>
@@ -3614,7 +3620,7 @@
               <a:buNone/>
             </a:pPr>
             <a:r>
-              <a:rPr lang="en-US" sz="900" b="1" dirty="0">
+              <a:rPr lang="en-US" sz="1800" b="1" dirty="0">
                 <a:solidFill>
                   <a:srgbClr val="5A667D"/>
                 </a:solidFill>
@@ -3624,7 +3630,7 @@
               </a:rPr>
               <a:t>REQUIREMENTS</a:t>
             </a:r>
-            <a:endParaRPr lang="en-US" sz="900" dirty="0"/>
+            <a:endParaRPr lang="en-US" sz="1800" dirty="0"/>
           </a:p>
         </p:txBody>
       </p:sp>
@@ -3655,7 +3661,7 @@
               <a:buNone/>
             </a:pPr>
             <a:r>
-              <a:rPr lang="en-US" sz="2600" b="1" dirty="0">
+              <a:rPr lang="en-US" sz="3000" b="1" dirty="0">
                 <a:solidFill>
                   <a:srgbClr val="172033"/>
                 </a:solidFill>
@@ -3665,7 +3671,7 @@
               </a:rPr>
               <a:t>Four simple requirements make inclusive visual review testable.</a:t>
             </a:r>
-            <a:endParaRPr lang="en-US" sz="2600" dirty="0"/>
+            <a:endParaRPr lang="en-US" sz="3000" dirty="0"/>
           </a:p>
         </p:txBody>
       </p:sp>
@@ -3702,44 +3708,8 @@
         </p:nvSpPr>
         <p:spPr>
           <a:xfrm>
-            <a:off x="960120" y="1837944"/>
-            <a:ext cx="2286000" cy="228600"/>
-          </a:xfrm>
-          <a:prstGeom prst="rect">
-            <a:avLst/>
-          </a:prstGeom>
-          <a:noFill/>
-          <a:ln/>
-        </p:spPr>
-        <p:txBody>
-          <a:bodyPr wrap="square" lIns="0" tIns="0" rIns="0" bIns="0" rtlCol="0" anchor="ctr"/>
-          <a:lstStyle/>
-          <a:p>
-            <a:pPr indent="0" marL="0">
-              <a:buNone/>
-            </a:pPr>
-            <a:r>
-              <a:rPr lang="en-US" sz="1250" b="1" dirty="0">
-                <a:solidFill>
-                  <a:srgbClr val="172033"/>
-                </a:solidFill>
-              </a:rPr>
-              <a:t>Readable colors</a:t>
-            </a:r>
-            <a:endParaRPr lang="en-US" sz="1250" dirty="0"/>
-          </a:p>
-        </p:txBody>
-      </p:sp>
-      <p:sp>
-        <p:nvSpPr>
-          <p:cNvPr id="7" name="Text 5"/>
-          <p:cNvSpPr/>
-          <p:nvPr/>
-        </p:nvSpPr>
-        <p:spPr>
-          <a:xfrm>
-            <a:off x="3657600" y="1837944"/>
-            <a:ext cx="6675120" cy="228600"/>
+            <a:off x="960120" y="1801368"/>
+            <a:ext cx="2468880" cy="320040"/>
           </a:xfrm>
           <a:prstGeom prst="rect">
             <a:avLst/>
@@ -3757,14 +3727,52 @@
               <a:buNone/>
             </a:pPr>
             <a:r>
-              <a:rPr lang="en-US" sz="1250" dirty="0">
+              <a:rPr lang="en-US" sz="1800" b="1" dirty="0">
                 <a:solidFill>
                   <a:srgbClr val="172033"/>
                 </a:solidFill>
               </a:rPr>
+              <a:t>Readable colors</a:t>
+            </a:r>
+            <a:endParaRPr lang="en-US" sz="1800" dirty="0"/>
+          </a:p>
+        </p:txBody>
+      </p:sp>
+      <p:sp>
+        <p:nvSpPr>
+          <p:cNvPr id="7" name="Text 5"/>
+          <p:cNvSpPr/>
+          <p:nvPr/>
+        </p:nvSpPr>
+        <p:spPr>
+          <a:xfrm>
+            <a:off x="3657600" y="1801368"/>
+            <a:ext cx="6675120" cy="320040"/>
+          </a:xfrm>
+          <a:prstGeom prst="rect">
+            <a:avLst/>
+          </a:prstGeom>
+          <a:noFill/>
+          <a:ln/>
+        </p:spPr>
+        <p:txBody>
+          <a:bodyPr wrap="square" lIns="0" tIns="0" rIns="0" bIns="0" rtlCol="0" anchor="ctr">
+            <a:normAutofit/>
+          </a:bodyPr>
+          <a:lstStyle/>
+          <a:p>
+            <a:pPr indent="0" marL="0">
+              <a:buNone/>
+            </a:pPr>
+            <a:r>
+              <a:rPr lang="en-US" sz="1800" dirty="0">
+                <a:solidFill>
+                  <a:srgbClr val="172033"/>
+                </a:solidFill>
+              </a:rPr>
               <a:t>Each data color reaches 3.0:1 contrast against background</a:t>
             </a:r>
-            <a:endParaRPr lang="en-US" sz="1250" dirty="0"/>
+            <a:endParaRPr lang="en-US" sz="1800" dirty="0"/>
           </a:p>
         </p:txBody>
       </p:sp>
@@ -3801,44 +3809,8 @@
         </p:nvSpPr>
         <p:spPr>
           <a:xfrm>
-            <a:off x="960120" y="2660904"/>
-            <a:ext cx="2286000" cy="228600"/>
-          </a:xfrm>
-          <a:prstGeom prst="rect">
-            <a:avLst/>
-          </a:prstGeom>
-          <a:noFill/>
-          <a:ln/>
-        </p:spPr>
-        <p:txBody>
-          <a:bodyPr wrap="square" lIns="0" tIns="0" rIns="0" bIns="0" rtlCol="0" anchor="ctr"/>
-          <a:lstStyle/>
-          <a:p>
-            <a:pPr indent="0" marL="0">
-              <a:buNone/>
-            </a:pPr>
-            <a:r>
-              <a:rPr lang="en-US" sz="1250" b="1" dirty="0">
-                <a:solidFill>
-                  <a:srgbClr val="172033"/>
-                </a:solidFill>
-              </a:rPr>
-              <a:t>Readable text</a:t>
-            </a:r>
-            <a:endParaRPr lang="en-US" sz="1250" dirty="0"/>
-          </a:p>
-        </p:txBody>
-      </p:sp>
-      <p:sp>
-        <p:nvSpPr>
-          <p:cNvPr id="10" name="Text 8"/>
-          <p:cNvSpPr/>
-          <p:nvPr/>
-        </p:nvSpPr>
-        <p:spPr>
-          <a:xfrm>
-            <a:off x="3657600" y="2660904"/>
-            <a:ext cx="6675120" cy="228600"/>
+            <a:off x="960120" y="2624328"/>
+            <a:ext cx="2468880" cy="320040"/>
           </a:xfrm>
           <a:prstGeom prst="rect">
             <a:avLst/>
@@ -3856,14 +3828,52 @@
               <a:buNone/>
             </a:pPr>
             <a:r>
-              <a:rPr lang="en-US" sz="1250" dirty="0">
+              <a:rPr lang="en-US" sz="1800" b="1" dirty="0">
                 <a:solidFill>
                   <a:srgbClr val="172033"/>
                 </a:solidFill>
               </a:rPr>
+              <a:t>Readable text</a:t>
+            </a:r>
+            <a:endParaRPr lang="en-US" sz="1800" dirty="0"/>
+          </a:p>
+        </p:txBody>
+      </p:sp>
+      <p:sp>
+        <p:nvSpPr>
+          <p:cNvPr id="10" name="Text 8"/>
+          <p:cNvSpPr/>
+          <p:nvPr/>
+        </p:nvSpPr>
+        <p:spPr>
+          <a:xfrm>
+            <a:off x="3657600" y="2624328"/>
+            <a:ext cx="6675120" cy="320040"/>
+          </a:xfrm>
+          <a:prstGeom prst="rect">
+            <a:avLst/>
+          </a:prstGeom>
+          <a:noFill/>
+          <a:ln/>
+        </p:spPr>
+        <p:txBody>
+          <a:bodyPr wrap="square" lIns="0" tIns="0" rIns="0" bIns="0" rtlCol="0" anchor="ctr">
+            <a:normAutofit/>
+          </a:bodyPr>
+          <a:lstStyle/>
+          <a:p>
+            <a:pPr indent="0" marL="0">
+              <a:buNone/>
+            </a:pPr>
+            <a:r>
+              <a:rPr lang="en-US" sz="1800" dirty="0">
+                <a:solidFill>
+                  <a:srgbClr val="172033"/>
+                </a:solidFill>
+              </a:rPr>
               <a:t>Font size is at least 12 pt</a:t>
             </a:r>
-            <a:endParaRPr lang="en-US" sz="1250" dirty="0"/>
+            <a:endParaRPr lang="en-US" sz="1800" dirty="0"/>
           </a:p>
         </p:txBody>
       </p:sp>
@@ -3900,44 +3910,8 @@
         </p:nvSpPr>
         <p:spPr>
           <a:xfrm>
-            <a:off x="960120" y="3483864"/>
-            <a:ext cx="2286000" cy="228600"/>
-          </a:xfrm>
-          <a:prstGeom prst="rect">
-            <a:avLst/>
-          </a:prstGeom>
-          <a:noFill/>
-          <a:ln/>
-        </p:spPr>
-        <p:txBody>
-          <a:bodyPr wrap="square" lIns="0" tIns="0" rIns="0" bIns="0" rtlCol="0" anchor="ctr"/>
-          <a:lstStyle/>
-          <a:p>
-            <a:pPr indent="0" marL="0">
-              <a:buNone/>
-            </a:pPr>
-            <a:r>
-              <a:rPr lang="en-US" sz="1250" b="1" dirty="0">
-                <a:solidFill>
-                  <a:srgbClr val="172033"/>
-                </a:solidFill>
-              </a:rPr>
-              <a:t>Clear context</a:t>
-            </a:r>
-            <a:endParaRPr lang="en-US" sz="1250" dirty="0"/>
-          </a:p>
-        </p:txBody>
-      </p:sp>
-      <p:sp>
-        <p:nvSpPr>
-          <p:cNvPr id="13" name="Text 11"/>
-          <p:cNvSpPr/>
-          <p:nvPr/>
-        </p:nvSpPr>
-        <p:spPr>
-          <a:xfrm>
-            <a:off x="3657600" y="3483864"/>
-            <a:ext cx="6675120" cy="228600"/>
+            <a:off x="960120" y="3447288"/>
+            <a:ext cx="2468880" cy="320040"/>
           </a:xfrm>
           <a:prstGeom prst="rect">
             <a:avLst/>
@@ -3955,14 +3929,52 @@
               <a:buNone/>
             </a:pPr>
             <a:r>
-              <a:rPr lang="en-US" sz="1250" dirty="0">
+              <a:rPr lang="en-US" sz="1800" b="1" dirty="0">
                 <a:solidFill>
                   <a:srgbClr val="172033"/>
                 </a:solidFill>
               </a:rPr>
+              <a:t>Clear context</a:t>
+            </a:r>
+            <a:endParaRPr lang="en-US" sz="1800" dirty="0"/>
+          </a:p>
+        </p:txBody>
+      </p:sp>
+      <p:sp>
+        <p:nvSpPr>
+          <p:cNvPr id="13" name="Text 11"/>
+          <p:cNvSpPr/>
+          <p:nvPr/>
+        </p:nvSpPr>
+        <p:spPr>
+          <a:xfrm>
+            <a:off x="3657600" y="3447288"/>
+            <a:ext cx="6675120" cy="320040"/>
+          </a:xfrm>
+          <a:prstGeom prst="rect">
+            <a:avLst/>
+          </a:prstGeom>
+          <a:noFill/>
+          <a:ln/>
+        </p:spPr>
+        <p:txBody>
+          <a:bodyPr wrap="square" lIns="0" tIns="0" rIns="0" bIns="0" rtlCol="0" anchor="ctr">
+            <a:normAutofit/>
+          </a:bodyPr>
+          <a:lstStyle/>
+          <a:p>
+            <a:pPr indent="0" marL="0">
+              <a:buNone/>
+            </a:pPr>
+            <a:r>
+              <a:rPr lang="en-US" sz="1800" dirty="0">
+                <a:solidFill>
+                  <a:srgbClr val="172033"/>
+                </a:solidFill>
+              </a:rPr>
               <a:t>Title, x-axis label, and y-axis label are present</a:t>
             </a:r>
-            <a:endParaRPr lang="en-US" sz="1250" dirty="0"/>
+            <a:endParaRPr lang="en-US" sz="1800" dirty="0"/>
           </a:p>
         </p:txBody>
       </p:sp>
@@ -3999,44 +4011,8 @@
         </p:nvSpPr>
         <p:spPr>
           <a:xfrm>
-            <a:off x="960120" y="4306824"/>
-            <a:ext cx="2286000" cy="228600"/>
-          </a:xfrm>
-          <a:prstGeom prst="rect">
-            <a:avLst/>
-          </a:prstGeom>
-          <a:noFill/>
-          <a:ln/>
-        </p:spPr>
-        <p:txBody>
-          <a:bodyPr wrap="square" lIns="0" tIns="0" rIns="0" bIns="0" rtlCol="0" anchor="ctr"/>
-          <a:lstStyle/>
-          <a:p>
-            <a:pPr indent="0" marL="0">
-              <a:buNone/>
-            </a:pPr>
-            <a:r>
-              <a:rPr lang="en-US" sz="1250" b="1" dirty="0">
-                <a:solidFill>
-                  <a:srgbClr val="172033"/>
-                </a:solidFill>
-              </a:rPr>
-              <a:t>Plain-language access</a:t>
-            </a:r>
-            <a:endParaRPr lang="en-US" sz="1250" dirty="0"/>
-          </a:p>
-        </p:txBody>
-      </p:sp>
-      <p:sp>
-        <p:nvSpPr>
-          <p:cNvPr id="16" name="Text 14"/>
-          <p:cNvSpPr/>
-          <p:nvPr/>
-        </p:nvSpPr>
-        <p:spPr>
-          <a:xfrm>
-            <a:off x="3657600" y="4306824"/>
-            <a:ext cx="6675120" cy="228600"/>
+            <a:off x="960120" y="4270248"/>
+            <a:ext cx="2468880" cy="320040"/>
           </a:xfrm>
           <a:prstGeom prst="rect">
             <a:avLst/>
@@ -4054,14 +4030,52 @@
               <a:buNone/>
             </a:pPr>
             <a:r>
-              <a:rPr lang="en-US" sz="1250" dirty="0">
+              <a:rPr lang="en-US" sz="1800" b="1" dirty="0">
                 <a:solidFill>
                   <a:srgbClr val="172033"/>
                 </a:solidFill>
               </a:rPr>
+              <a:t>Plain-language access</a:t>
+            </a:r>
+            <a:endParaRPr lang="en-US" sz="1800" dirty="0"/>
+          </a:p>
+        </p:txBody>
+      </p:sp>
+      <p:sp>
+        <p:nvSpPr>
+          <p:cNvPr id="16" name="Text 14"/>
+          <p:cNvSpPr/>
+          <p:nvPr/>
+        </p:nvSpPr>
+        <p:spPr>
+          <a:xfrm>
+            <a:off x="3657600" y="4270248"/>
+            <a:ext cx="6675120" cy="320040"/>
+          </a:xfrm>
+          <a:prstGeom prst="rect">
+            <a:avLst/>
+          </a:prstGeom>
+          <a:noFill/>
+          <a:ln/>
+        </p:spPr>
+        <p:txBody>
+          <a:bodyPr wrap="square" lIns="0" tIns="0" rIns="0" bIns="0" rtlCol="0" anchor="ctr">
+            <a:normAutofit/>
+          </a:bodyPr>
+          <a:lstStyle/>
+          <a:p>
+            <a:pPr indent="0" marL="0">
+              <a:buNone/>
+            </a:pPr>
+            <a:r>
+              <a:rPr lang="en-US" sz="1800" dirty="0">
+                <a:solidFill>
+                  <a:srgbClr val="172033"/>
+                </a:solidFill>
+              </a:rPr>
               <a:t>Alt text has at least 8 words</a:t>
             </a:r>
-            <a:endParaRPr lang="en-US" sz="1250" dirty="0"/>
+            <a:endParaRPr lang="en-US" sz="1800" dirty="0"/>
           </a:p>
         </p:txBody>
       </p:sp>
@@ -4073,8 +4087,8 @@
         </p:nvSpPr>
         <p:spPr>
           <a:xfrm>
-            <a:off x="502920" y="6446520"/>
-            <a:ext cx="2926080" cy="182880"/>
+            <a:off x="502920" y="6263640"/>
+            <a:ext cx="4023360" cy="320040"/>
           </a:xfrm>
           <a:prstGeom prst="rect">
             <a:avLst/>
@@ -4090,14 +4104,14 @@
               <a:buNone/>
             </a:pPr>
             <a:r>
-              <a:rPr lang="en-US" sz="750" dirty="0">
+              <a:rPr lang="en-US" sz="1800" dirty="0">
                 <a:solidFill>
                   <a:srgbClr val="5A667D"/>
                 </a:solidFill>
               </a:rPr>
               <a:t>SYSEN 5493 final project  /  4</a:t>
             </a:r>
-            <a:endParaRPr lang="en-US" sz="750" dirty="0"/>
+            <a:endParaRPr lang="en-US" sz="1800" dirty="0"/>
           </a:p>
         </p:txBody>
       </p:sp>
@@ -4138,7 +4152,7 @@
     <p:bg>
       <p:bgPr>
         <a:solidFill>
-          <a:srgbClr val="F7F5EF"/>
+          <a:srgbClr val="FFFFFF"/>
         </a:solidFill>
       </p:bgPr>
     </p:bg>
@@ -4206,7 +4220,7 @@
               <a:buNone/>
             </a:pPr>
             <a:r>
-              <a:rPr lang="en-US" sz="900" b="1" dirty="0">
+              <a:rPr lang="en-US" sz="1800" b="1" dirty="0">
                 <a:solidFill>
                   <a:srgbClr val="5A667D"/>
                 </a:solidFill>
@@ -4216,7 +4230,7 @@
               </a:rPr>
               <a:t>REAL VISUAL AUDIT</a:t>
             </a:r>
-            <a:endParaRPr lang="en-US" sz="900" dirty="0"/>
+            <a:endParaRPr lang="en-US" sz="1800" dirty="0"/>
           </a:p>
         </p:txBody>
       </p:sp>
@@ -4247,7 +4261,7 @@
               <a:buNone/>
             </a:pPr>
             <a:r>
-              <a:rPr lang="en-US" sz="2600" b="1" dirty="0">
+              <a:rPr lang="en-US" sz="3000" b="1" dirty="0">
                 <a:solidFill>
                   <a:srgbClr val="172033"/>
                 </a:solidFill>
@@ -4257,7 +4271,7 @@
               </a:rPr>
               <a:t>The upload workflow passes three real thesis and poster visuals.</a:t>
             </a:r>
-            <a:endParaRPr lang="en-US" sz="2600" dirty="0"/>
+            <a:endParaRPr lang="en-US" sz="3000" dirty="0"/>
           </a:p>
         </p:txBody>
       </p:sp>
@@ -4318,8 +4332,8 @@
         </p:nvSpPr>
         <p:spPr>
           <a:xfrm>
-            <a:off x="3840480" y="1645920"/>
-            <a:ext cx="3566160" cy="228600"/>
+            <a:off x="3840480" y="1609344"/>
+            <a:ext cx="4389120" cy="384048"/>
           </a:xfrm>
           <a:prstGeom prst="rect">
             <a:avLst/>
@@ -4337,14 +4351,14 @@
               <a:buNone/>
             </a:pPr>
             <a:r>
-              <a:rPr lang="en-US" sz="1320" b="1" dirty="0">
+              <a:rPr lang="en-US" sz="1800" b="1" dirty="0">
                 <a:solidFill>
                   <a:srgbClr val="172033"/>
                 </a:solidFill>
               </a:rPr>
               <a:t>Thesis: Consequence Proximity</a:t>
             </a:r>
-            <a:endParaRPr lang="en-US" sz="1320" dirty="0"/>
+            <a:endParaRPr lang="en-US" sz="1800" dirty="0"/>
           </a:p>
         </p:txBody>
       </p:sp>
@@ -4402,14 +4416,14 @@
               <a:buNone/>
             </a:pPr>
             <a:r>
-              <a:rPr lang="en-US" sz="950" b="1" dirty="0">
+              <a:rPr lang="en-US" sz="1800" b="1" dirty="0">
                 <a:solidFill>
                   <a:srgbClr val="009E73"/>
                 </a:solidFill>
               </a:rPr>
               <a:t>PASS 4/4  |  text/marks 2.2%  |  low-contrast share 47.9%</a:t>
             </a:r>
-            <a:endParaRPr lang="en-US" sz="950" dirty="0"/>
+            <a:endParaRPr lang="en-US" sz="1800" dirty="0"/>
           </a:p>
         </p:txBody>
       </p:sp>
@@ -4470,8 +4484,8 @@
         </p:nvSpPr>
         <p:spPr>
           <a:xfrm>
-            <a:off x="3840480" y="2926080"/>
-            <a:ext cx="3566160" cy="228600"/>
+            <a:off x="3840480" y="2889504"/>
+            <a:ext cx="4389120" cy="384048"/>
           </a:xfrm>
           <a:prstGeom prst="rect">
             <a:avLst/>
@@ -4489,14 +4503,14 @@
               <a:buNone/>
             </a:pPr>
             <a:r>
-              <a:rPr lang="en-US" sz="1320" b="1" dirty="0">
+              <a:rPr lang="en-US" sz="1800" b="1" dirty="0">
                 <a:solidFill>
                   <a:srgbClr val="172033"/>
                 </a:solidFill>
               </a:rPr>
               <a:t>Thesis: Inaccurate Causes</a:t>
             </a:r>
-            <a:endParaRPr lang="en-US" sz="1320" dirty="0"/>
+            <a:endParaRPr lang="en-US" sz="1800" dirty="0"/>
           </a:p>
         </p:txBody>
       </p:sp>
@@ -4554,14 +4568,14 @@
               <a:buNone/>
             </a:pPr>
             <a:r>
-              <a:rPr lang="en-US" sz="950" b="1" dirty="0">
+              <a:rPr lang="en-US" sz="1800" b="1" dirty="0">
                 <a:solidFill>
                   <a:srgbClr val="009E73"/>
                 </a:solidFill>
               </a:rPr>
               <a:t>PASS 4/4  |  text/marks 5.7%  |  low-contrast share 56.4%</a:t>
             </a:r>
-            <a:endParaRPr lang="en-US" sz="950" dirty="0"/>
+            <a:endParaRPr lang="en-US" sz="1800" dirty="0"/>
           </a:p>
         </p:txBody>
       </p:sp>
@@ -4622,8 +4636,8 @@
         </p:nvSpPr>
         <p:spPr>
           <a:xfrm>
-            <a:off x="3840480" y="4206240"/>
-            <a:ext cx="3566160" cy="228600"/>
+            <a:off x="3840480" y="4169664"/>
+            <a:ext cx="4389120" cy="384048"/>
           </a:xfrm>
           <a:prstGeom prst="rect">
             <a:avLst/>
@@ -4641,14 +4655,14 @@
               <a:buNone/>
             </a:pPr>
             <a:r>
-              <a:rPr lang="en-US" sz="1320" b="1" dirty="0">
+              <a:rPr lang="en-US" sz="1800" b="1" dirty="0">
                 <a:solidFill>
                   <a:srgbClr val="172033"/>
                 </a:solidFill>
               </a:rPr>
               <a:t>Poster: Emotions Table</a:t>
             </a:r>
-            <a:endParaRPr lang="en-US" sz="1320" dirty="0"/>
+            <a:endParaRPr lang="en-US" sz="1800" dirty="0"/>
           </a:p>
         </p:txBody>
       </p:sp>
@@ -4706,14 +4720,14 @@
               <a:buNone/>
             </a:pPr>
             <a:r>
-              <a:rPr lang="en-US" sz="950" b="1" dirty="0">
+              <a:rPr lang="en-US" sz="1800" b="1" dirty="0">
                 <a:solidFill>
                   <a:srgbClr val="009E73"/>
                 </a:solidFill>
               </a:rPr>
               <a:t>PASS 4/4  |  text/marks 45.5%  |  low-contrast share 38.0%</a:t>
             </a:r>
-            <a:endParaRPr lang="en-US" sz="950" dirty="0"/>
+            <a:endParaRPr lang="en-US" sz="1800" dirty="0"/>
           </a:p>
         </p:txBody>
       </p:sp>
@@ -4751,7 +4765,7 @@
         <p:spPr>
           <a:xfrm>
             <a:off x="9162288" y="1956816"/>
-            <a:ext cx="1874520" cy="320040"/>
+            <a:ext cx="1874520" cy="502920"/>
           </a:xfrm>
           <a:prstGeom prst="rect">
             <a:avLst/>
@@ -4769,14 +4783,14 @@
               <a:buNone/>
             </a:pPr>
             <a:r>
-              <a:rPr lang="en-US" sz="1450" b="1" dirty="0">
+              <a:rPr lang="en-US" sz="1800" b="1" dirty="0">
                 <a:solidFill>
                   <a:srgbClr val="005AB5"/>
                 </a:solidFill>
               </a:rPr>
               <a:t>Human review still matters</a:t>
             </a:r>
-            <a:endParaRPr lang="en-US" sz="1450" dirty="0"/>
+            <a:endParaRPr lang="en-US" sz="1800" dirty="0"/>
           </a:p>
         </p:txBody>
       </p:sp>
@@ -4807,14 +4821,14 @@
               <a:buNone/>
             </a:pPr>
             <a:r>
-              <a:rPr lang="en-US" sz="1250" dirty="0">
+              <a:rPr lang="en-US" sz="1800" dirty="0">
                 <a:solidFill>
                   <a:srgbClr val="172033"/>
                 </a:solidFill>
               </a:rPr>
               <a:t>The pixel audit checks readability signals. A human should still improve semantic labels such as TRUE/FALSE legends and confirm the visual tells the intended story.</a:t>
             </a:r>
-            <a:endParaRPr lang="en-US" sz="1250" dirty="0"/>
+            <a:endParaRPr lang="en-US" sz="1800" dirty="0"/>
           </a:p>
         </p:txBody>
       </p:sp>
@@ -4826,8 +4840,8 @@
         </p:nvSpPr>
         <p:spPr>
           <a:xfrm>
-            <a:off x="502920" y="6446520"/>
-            <a:ext cx="2926080" cy="182880"/>
+            <a:off x="502920" y="6263640"/>
+            <a:ext cx="4023360" cy="320040"/>
           </a:xfrm>
           <a:prstGeom prst="rect">
             <a:avLst/>
@@ -4843,14 +4857,14 @@
               <a:buNone/>
             </a:pPr>
             <a:r>
-              <a:rPr lang="en-US" sz="750" dirty="0">
+              <a:rPr lang="en-US" sz="1800" dirty="0">
                 <a:solidFill>
                   <a:srgbClr val="5A667D"/>
                 </a:solidFill>
               </a:rPr>
               <a:t>SYSEN 5493 final project  /  5</a:t>
             </a:r>
-            <a:endParaRPr lang="en-US" sz="750" dirty="0"/>
+            <a:endParaRPr lang="en-US" sz="1800" dirty="0"/>
           </a:p>
         </p:txBody>
       </p:sp>
@@ -4891,7 +4905,7 @@
     <p:bg>
       <p:bgPr>
         <a:solidFill>
-          <a:srgbClr val="F7F5EF"/>
+          <a:srgbClr val="FFFFFF"/>
         </a:solidFill>
       </p:bgPr>
     </p:bg>
@@ -4959,7 +4973,7 @@
               <a:buNone/>
             </a:pPr>
             <a:r>
-              <a:rPr lang="en-US" sz="900" b="1" dirty="0">
+              <a:rPr lang="en-US" sz="1800" b="1" dirty="0">
                 <a:solidFill>
                   <a:srgbClr val="5A667D"/>
                 </a:solidFill>
@@ -4969,7 +4983,7 @@
               </a:rPr>
               <a:t>GIT HYGIENE</a:t>
             </a:r>
-            <a:endParaRPr lang="en-US" sz="900" dirty="0"/>
+            <a:endParaRPr lang="en-US" sz="1800" dirty="0"/>
           </a:p>
         </p:txBody>
       </p:sp>
@@ -5000,7 +5014,7 @@
               <a:buNone/>
             </a:pPr>
             <a:r>
-              <a:rPr lang="en-US" sz="2600" b="1" dirty="0">
+              <a:rPr lang="en-US" sz="3000" b="1" dirty="0">
                 <a:solidFill>
                   <a:srgbClr val="172033"/>
                 </a:solidFill>
@@ -5010,7 +5024,7 @@
               </a:rPr>
               <a:t>The commit history tells the project story.</a:t>
             </a:r>
-            <a:endParaRPr lang="en-US" sz="2600" dirty="0"/>
+            <a:endParaRPr lang="en-US" sz="3000" dirty="0"/>
           </a:p>
         </p:txBody>
       </p:sp>
@@ -5071,23 +5085,25 @@
         <p:spPr>
           <a:xfrm>
             <a:off x="1325880" y="1691640"/>
-            <a:ext cx="5303520" cy="274320"/>
-          </a:xfrm>
-          <a:prstGeom prst="rect">
-            <a:avLst/>
-          </a:prstGeom>
-          <a:noFill/>
-          <a:ln/>
-        </p:spPr>
-        <p:txBody>
-          <a:bodyPr wrap="square" lIns="0" tIns="0" rIns="0" bIns="0" rtlCol="0" anchor="ctr"/>
-          <a:lstStyle/>
-          <a:p>
-            <a:pPr indent="0" marL="0">
-              <a:buNone/>
-            </a:pPr>
-            <a:r>
-              <a:rPr lang="en-US" sz="1250" dirty="0">
+            <a:ext cx="5669280" cy="347472"/>
+          </a:xfrm>
+          <a:prstGeom prst="rect">
+            <a:avLst/>
+          </a:prstGeom>
+          <a:noFill/>
+          <a:ln/>
+        </p:spPr>
+        <p:txBody>
+          <a:bodyPr wrap="square" lIns="0" tIns="0" rIns="0" bIns="0" rtlCol="0" anchor="ctr">
+            <a:normAutofit/>
+          </a:bodyPr>
+          <a:lstStyle/>
+          <a:p>
+            <a:pPr indent="0" marL="0">
+              <a:buNone/>
+            </a:pPr>
+            <a:r>
+              <a:rPr lang="en-US" sz="1800" dirty="0">
                 <a:solidFill>
                   <a:srgbClr val="172033"/>
                 </a:solidFill>
@@ -5097,7 +5113,7 @@
               </a:rPr>
               <a:t>docs: initialize project</a:t>
             </a:r>
-            <a:endParaRPr lang="en-US" sz="1250" dirty="0"/>
+            <a:endParaRPr lang="en-US" sz="1800" dirty="0"/>
           </a:p>
         </p:txBody>
       </p:sp>
@@ -5158,23 +5174,25 @@
         <p:spPr>
           <a:xfrm>
             <a:off x="1325880" y="2258568"/>
-            <a:ext cx="5303520" cy="274320"/>
-          </a:xfrm>
-          <a:prstGeom prst="rect">
-            <a:avLst/>
-          </a:prstGeom>
-          <a:noFill/>
-          <a:ln/>
-        </p:spPr>
-        <p:txBody>
-          <a:bodyPr wrap="square" lIns="0" tIns="0" rIns="0" bIns="0" rtlCol="0" anchor="ctr"/>
-          <a:lstStyle/>
-          <a:p>
-            <a:pPr indent="0" marL="0">
-              <a:buNone/>
-            </a:pPr>
-            <a:r>
-              <a:rPr lang="en-US" sz="1250" dirty="0">
+            <a:ext cx="5669280" cy="347472"/>
+          </a:xfrm>
+          <a:prstGeom prst="rect">
+            <a:avLst/>
+          </a:prstGeom>
+          <a:noFill/>
+          <a:ln/>
+        </p:spPr>
+        <p:txBody>
+          <a:bodyPr wrap="square" lIns="0" tIns="0" rIns="0" bIns="0" rtlCol="0" anchor="ctr">
+            <a:normAutofit/>
+          </a:bodyPr>
+          <a:lstStyle/>
+          <a:p>
+            <a:pPr indent="0" marL="0">
+              <a:buNone/>
+            </a:pPr>
+            <a:r>
+              <a:rPr lang="en-US" sz="1800" dirty="0">
                 <a:solidFill>
                   <a:srgbClr val="172033"/>
                 </a:solidFill>
@@ -5184,7 +5202,7 @@
               </a:rPr>
               <a:t>feat(color): add contrast utilities</a:t>
             </a:r>
-            <a:endParaRPr lang="en-US" sz="1250" dirty="0"/>
+            <a:endParaRPr lang="en-US" sz="1800" dirty="0"/>
           </a:p>
         </p:txBody>
       </p:sp>
@@ -5245,23 +5263,25 @@
         <p:spPr>
           <a:xfrm>
             <a:off x="1325880" y="2825496"/>
-            <a:ext cx="5303520" cy="274320"/>
-          </a:xfrm>
-          <a:prstGeom prst="rect">
-            <a:avLst/>
-          </a:prstGeom>
-          <a:noFill/>
-          <a:ln/>
-        </p:spPr>
-        <p:txBody>
-          <a:bodyPr wrap="square" lIns="0" tIns="0" rIns="0" bIns="0" rtlCol="0" anchor="ctr"/>
-          <a:lstStyle/>
-          <a:p>
-            <a:pPr indent="0" marL="0">
-              <a:buNone/>
-            </a:pPr>
-            <a:r>
-              <a:rPr lang="en-US" sz="1250" dirty="0">
+            <a:ext cx="5669280" cy="347472"/>
+          </a:xfrm>
+          <a:prstGeom prst="rect">
+            <a:avLst/>
+          </a:prstGeom>
+          <a:noFill/>
+          <a:ln/>
+        </p:spPr>
+        <p:txBody>
+          <a:bodyPr wrap="square" lIns="0" tIns="0" rIns="0" bIns="0" rtlCol="0" anchor="ctr">
+            <a:normAutofit/>
+          </a:bodyPr>
+          <a:lstStyle/>
+          <a:p>
+            <a:pPr indent="0" marL="0">
+              <a:buNone/>
+            </a:pPr>
+            <a:r>
+              <a:rPr lang="en-US" sz="1800" dirty="0">
                 <a:solidFill>
                   <a:srgbClr val="172033"/>
                 </a:solidFill>
@@ -5271,7 +5291,7 @@
               </a:rPr>
               <a:t>feat(audit): evaluate requirements</a:t>
             </a:r>
-            <a:endParaRPr lang="en-US" sz="1250" dirty="0"/>
+            <a:endParaRPr lang="en-US" sz="1800" dirty="0"/>
           </a:p>
         </p:txBody>
       </p:sp>
@@ -5332,23 +5352,25 @@
         <p:spPr>
           <a:xfrm>
             <a:off x="1325880" y="3392424"/>
-            <a:ext cx="5303520" cy="274320"/>
-          </a:xfrm>
-          <a:prstGeom prst="rect">
-            <a:avLst/>
-          </a:prstGeom>
-          <a:noFill/>
-          <a:ln/>
-        </p:spPr>
-        <p:txBody>
-          <a:bodyPr wrap="square" lIns="0" tIns="0" rIns="0" bIns="0" rtlCol="0" anchor="ctr"/>
-          <a:lstStyle/>
-          <a:p>
-            <a:pPr indent="0" marL="0">
-              <a:buNone/>
-            </a:pPr>
-            <a:r>
-              <a:rPr lang="en-US" sz="1250" dirty="0">
+            <a:ext cx="5669280" cy="347472"/>
+          </a:xfrm>
+          <a:prstGeom prst="rect">
+            <a:avLst/>
+          </a:prstGeom>
+          <a:noFill/>
+          <a:ln/>
+        </p:spPr>
+        <p:txBody>
+          <a:bodyPr wrap="square" lIns="0" tIns="0" rIns="0" bIns="0" rtlCol="0" anchor="ctr">
+            <a:normAutofit/>
+          </a:bodyPr>
+          <a:lstStyle/>
+          <a:p>
+            <a:pPr indent="0" marL="0">
+              <a:buNone/>
+            </a:pPr>
+            <a:r>
+              <a:rPr lang="en-US" sz="1800" dirty="0">
                 <a:solidFill>
                   <a:srgbClr val="172033"/>
                 </a:solidFill>
@@ -5358,7 +5380,7 @@
               </a:rPr>
               <a:t>test(audit): cover requirements</a:t>
             </a:r>
-            <a:endParaRPr lang="en-US" sz="1250" dirty="0"/>
+            <a:endParaRPr lang="en-US" sz="1800" dirty="0"/>
           </a:p>
         </p:txBody>
       </p:sp>
@@ -5419,23 +5441,25 @@
         <p:spPr>
           <a:xfrm>
             <a:off x="1325880" y="3959352"/>
-            <a:ext cx="5303520" cy="274320"/>
-          </a:xfrm>
-          <a:prstGeom prst="rect">
-            <a:avLst/>
-          </a:prstGeom>
-          <a:noFill/>
-          <a:ln/>
-        </p:spPr>
-        <p:txBody>
-          <a:bodyPr wrap="square" lIns="0" tIns="0" rIns="0" bIns="0" rtlCol="0" anchor="ctr"/>
-          <a:lstStyle/>
-          <a:p>
-            <a:pPr indent="0" marL="0">
-              <a:buNone/>
-            </a:pPr>
-            <a:r>
-              <a:rPr lang="en-US" sz="1250" dirty="0">
+            <a:ext cx="5669280" cy="347472"/>
+          </a:xfrm>
+          <a:prstGeom prst="rect">
+            <a:avLst/>
+          </a:prstGeom>
+          <a:noFill/>
+          <a:ln/>
+        </p:spPr>
+        <p:txBody>
+          <a:bodyPr wrap="square" lIns="0" tIns="0" rIns="0" bIns="0" rtlCol="0" anchor="ctr">
+            <a:normAutofit/>
+          </a:bodyPr>
+          <a:lstStyle/>
+          <a:p>
+            <a:pPr indent="0" marL="0">
+              <a:buNone/>
+            </a:pPr>
+            <a:r>
+              <a:rPr lang="en-US" sz="1800" dirty="0">
                 <a:solidFill>
                   <a:srgbClr val="172033"/>
                 </a:solidFill>
@@ -5445,7 +5469,7 @@
               </a:rPr>
               <a:t>ci: add unit test workflow</a:t>
             </a:r>
-            <a:endParaRPr lang="en-US" sz="1250" dirty="0"/>
+            <a:endParaRPr lang="en-US" sz="1800" dirty="0"/>
           </a:p>
         </p:txBody>
       </p:sp>
@@ -5483,23 +5507,25 @@
         <p:spPr>
           <a:xfrm>
             <a:off x="1325880" y="4526280"/>
-            <a:ext cx="5303520" cy="274320"/>
-          </a:xfrm>
-          <a:prstGeom prst="rect">
-            <a:avLst/>
-          </a:prstGeom>
-          <a:noFill/>
-          <a:ln/>
-        </p:spPr>
-        <p:txBody>
-          <a:bodyPr wrap="square" lIns="0" tIns="0" rIns="0" bIns="0" rtlCol="0" anchor="ctr"/>
-          <a:lstStyle/>
-          <a:p>
-            <a:pPr indent="0" marL="0">
-              <a:buNone/>
-            </a:pPr>
-            <a:r>
-              <a:rPr lang="en-US" sz="1250" dirty="0">
+            <a:ext cx="5669280" cy="347472"/>
+          </a:xfrm>
+          <a:prstGeom prst="rect">
+            <a:avLst/>
+          </a:prstGeom>
+          <a:noFill/>
+          <a:ln/>
+        </p:spPr>
+        <p:txBody>
+          <a:bodyPr wrap="square" lIns="0" tIns="0" rIns="0" bIns="0" rtlCol="0" anchor="ctr">
+            <a:normAutofit/>
+          </a:bodyPr>
+          <a:lstStyle/>
+          <a:p>
+            <a:pPr indent="0" marL="0">
+              <a:buNone/>
+            </a:pPr>
+            <a:r>
+              <a:rPr lang="en-US" sz="1800" dirty="0">
                 <a:solidFill>
                   <a:srgbClr val="172033"/>
                 </a:solidFill>
@@ -5509,7 +5535,7 @@
               </a:rPr>
               <a:t>merge: resolve font-size policy conflict</a:t>
             </a:r>
-            <a:endParaRPr lang="en-US" sz="1250" dirty="0"/>
+            <a:endParaRPr lang="en-US" sz="1800" dirty="0"/>
           </a:p>
         </p:txBody>
       </p:sp>
@@ -5541,14 +5567,14 @@
               <a:buChar char="•"/>
             </a:pPr>
             <a:r>
-              <a:rPr lang="en-US" sz="1350" dirty="0">
+              <a:rPr lang="en-US" sz="1800" dirty="0">
                 <a:solidFill>
                   <a:srgbClr val="172033"/>
                 </a:solidFill>
               </a:rPr>
               <a:t>Conventional commits read like a changelog.</a:t>
             </a:r>
-            <a:endParaRPr lang="en-US" sz="1350" dirty="0"/>
+            <a:endParaRPr lang="en-US" sz="1800" dirty="0"/>
           </a:p>
           <a:p>
             <a:pPr marL="152400" indent="-152400">
@@ -5556,14 +5582,14 @@
               <a:buChar char="•"/>
             </a:pPr>
             <a:r>
-              <a:rPr lang="en-US" sz="1350" dirty="0">
+              <a:rPr lang="en-US" sz="1800" dirty="0">
                 <a:solidFill>
                   <a:srgbClr val="172033"/>
                 </a:solidFill>
               </a:rPr>
               <a:t>A feature branch was merged with --no-ff.</a:t>
             </a:r>
-            <a:endParaRPr lang="en-US" sz="1350" dirty="0"/>
+            <a:endParaRPr lang="en-US" sz="1800" dirty="0"/>
           </a:p>
           <a:p>
             <a:pPr marL="152400" indent="-152400">
@@ -5571,14 +5597,14 @@
               <a:buChar char="•"/>
             </a:pPr>
             <a:r>
-              <a:rPr lang="en-US" sz="1350" dirty="0">
+              <a:rPr lang="en-US" sz="1800" dirty="0">
                 <a:solidFill>
                   <a:srgbClr val="172033"/>
                 </a:solidFill>
               </a:rPr>
               <a:t>A deliberate conflict forced a human policy choice.</a:t>
             </a:r>
-            <a:endParaRPr lang="en-US" sz="1350" dirty="0"/>
+            <a:endParaRPr lang="en-US" sz="1800" dirty="0"/>
           </a:p>
         </p:txBody>
       </p:sp>
@@ -5590,8 +5616,8 @@
         </p:nvSpPr>
         <p:spPr>
           <a:xfrm>
-            <a:off x="502920" y="6446520"/>
-            <a:ext cx="2926080" cy="182880"/>
+            <a:off x="502920" y="6263640"/>
+            <a:ext cx="4023360" cy="320040"/>
           </a:xfrm>
           <a:prstGeom prst="rect">
             <a:avLst/>
@@ -5607,14 +5633,14 @@
               <a:buNone/>
             </a:pPr>
             <a:r>
-              <a:rPr lang="en-US" sz="750" dirty="0">
+              <a:rPr lang="en-US" sz="1800" dirty="0">
                 <a:solidFill>
                   <a:srgbClr val="5A667D"/>
                 </a:solidFill>
               </a:rPr>
               <a:t>SYSEN 5493 final project  /  6</a:t>
             </a:r>
-            <a:endParaRPr lang="en-US" sz="750" dirty="0"/>
+            <a:endParaRPr lang="en-US" sz="1800" dirty="0"/>
           </a:p>
         </p:txBody>
       </p:sp>
@@ -5655,7 +5681,7 @@
     <p:bg>
       <p:bgPr>
         <a:solidFill>
-          <a:srgbClr val="F7F5EF"/>
+          <a:srgbClr val="FFFFFF"/>
         </a:solidFill>
       </p:bgPr>
     </p:bg>
@@ -5723,7 +5749,7 @@
               <a:buNone/>
             </a:pPr>
             <a:r>
-              <a:rPr lang="en-US" sz="900" b="1" dirty="0">
+              <a:rPr lang="en-US" sz="1800" b="1" dirty="0">
                 <a:solidFill>
                   <a:srgbClr val="5A667D"/>
                 </a:solidFill>
@@ -5733,7 +5759,7 @@
               </a:rPr>
               <a:t>AI COLLABORATION</a:t>
             </a:r>
-            <a:endParaRPr lang="en-US" sz="900" dirty="0"/>
+            <a:endParaRPr lang="en-US" sz="1800" dirty="0"/>
           </a:p>
         </p:txBody>
       </p:sp>
@@ -5764,7 +5790,7 @@
               <a:buNone/>
             </a:pPr>
             <a:r>
-              <a:rPr lang="en-US" sz="2600" b="1" dirty="0">
+              <a:rPr lang="en-US" sz="3000" b="1" dirty="0">
                 <a:solidFill>
                   <a:srgbClr val="172033"/>
                 </a:solidFill>
@@ -5774,7 +5800,7 @@
               </a:rPr>
               <a:t>AI drafted options; I kept the requirements accountable.</a:t>
             </a:r>
-            <a:endParaRPr lang="en-US" sz="2600" dirty="0"/>
+            <a:endParaRPr lang="en-US" sz="3000" dirty="0"/>
           </a:p>
         </p:txBody>
       </p:sp>
@@ -5812,7 +5838,7 @@
         <p:spPr>
           <a:xfrm>
             <a:off x="1005840" y="1901952"/>
-            <a:ext cx="914400" cy="228600"/>
+            <a:ext cx="1188720" cy="347472"/>
           </a:xfrm>
           <a:prstGeom prst="rect">
             <a:avLst/>
@@ -5828,14 +5854,14 @@
               <a:buNone/>
             </a:pPr>
             <a:r>
-              <a:rPr lang="en-US" sz="1200" b="1" dirty="0">
+              <a:rPr lang="en-US" sz="1800" b="1" dirty="0">
                 <a:solidFill>
                   <a:srgbClr val="005AB5"/>
                 </a:solidFill>
               </a:rPr>
               <a:t>Prompt</a:t>
             </a:r>
-            <a:endParaRPr lang="en-US" sz="1200" dirty="0"/>
+            <a:endParaRPr lang="en-US" sz="1800" dirty="0"/>
           </a:p>
         </p:txBody>
       </p:sp>
@@ -5866,14 +5892,14 @@
               <a:buNone/>
             </a:pPr>
             <a:r>
-              <a:rPr lang="en-US" sz="1600" i="1" dirty="0">
+              <a:rPr lang="en-US" sz="1800" i="1" dirty="0">
                 <a:solidFill>
                   <a:srgbClr val="172033"/>
                 </a:solidFill>
               </a:rPr>
               <a:t>"Help me design a simple systems-engineering final project that checks whether graphs meet ADA and inclusivity requirements for color and font choices."</a:t>
             </a:r>
-            <a:endParaRPr lang="en-US" sz="1600" dirty="0"/>
+            <a:endParaRPr lang="en-US" sz="1800" dirty="0"/>
           </a:p>
         </p:txBody>
       </p:sp>
@@ -5930,14 +5956,14 @@
               <a:buChar char="•"/>
             </a:pPr>
             <a:r>
-              <a:rPr lang="en-US" sz="1350" dirty="0">
+              <a:rPr lang="en-US" sz="1800" dirty="0">
                 <a:solidFill>
                   <a:srgbClr val="172033"/>
                 </a:solidFill>
               </a:rPr>
               <a:t>Accepted: JSON metadata instead of image parsing.</a:t>
             </a:r>
-            <a:endParaRPr lang="en-US" sz="1350" dirty="0"/>
+            <a:endParaRPr lang="en-US" sz="1800" dirty="0"/>
           </a:p>
           <a:p>
             <a:pPr marL="152400" indent="-152400">
@@ -5945,14 +5971,14 @@
               <a:buChar char="•"/>
             </a:pPr>
             <a:r>
-              <a:rPr lang="en-US" sz="1350" dirty="0">
+              <a:rPr lang="en-US" sz="1800" dirty="0">
                 <a:solidFill>
                   <a:srgbClr val="172033"/>
                 </a:solidFill>
               </a:rPr>
               <a:t>Accepted: requirement checks that are easy to test.</a:t>
             </a:r>
-            <a:endParaRPr lang="en-US" sz="1350" dirty="0"/>
+            <a:endParaRPr lang="en-US" sz="1800" dirty="0"/>
           </a:p>
           <a:p>
             <a:pPr marL="152400" indent="-152400">
@@ -5960,14 +5986,14 @@
               <a:buChar char="•"/>
             </a:pPr>
             <a:r>
-              <a:rPr lang="en-US" sz="1350" dirty="0">
+              <a:rPr lang="en-US" sz="1800" dirty="0">
                 <a:solidFill>
                   <a:srgbClr val="172033"/>
                 </a:solidFill>
               </a:rPr>
               <a:t>Rejected: vague AI accessibility score.</a:t>
             </a:r>
-            <a:endParaRPr lang="en-US" sz="1350" dirty="0"/>
+            <a:endParaRPr lang="en-US" sz="1800" dirty="0"/>
           </a:p>
           <a:p>
             <a:pPr marL="152400" indent="-152400">
@@ -5975,14 +6001,14 @@
               <a:buChar char="•"/>
             </a:pPr>
             <a:r>
-              <a:rPr lang="en-US" sz="1350" dirty="0">
+              <a:rPr lang="en-US" sz="1800" dirty="0">
                 <a:solidFill>
                   <a:srgbClr val="172033"/>
                 </a:solidFill>
               </a:rPr>
               <a:t>Rejected: heavy computer-vision scope.</a:t>
             </a:r>
-            <a:endParaRPr lang="en-US" sz="1350" dirty="0"/>
+            <a:endParaRPr lang="en-US" sz="1800" dirty="0"/>
           </a:p>
         </p:txBody>
       </p:sp>
@@ -5994,8 +6020,8 @@
         </p:nvSpPr>
         <p:spPr>
           <a:xfrm>
-            <a:off x="502920" y="6446520"/>
-            <a:ext cx="2926080" cy="182880"/>
+            <a:off x="502920" y="6263640"/>
+            <a:ext cx="4023360" cy="320040"/>
           </a:xfrm>
           <a:prstGeom prst="rect">
             <a:avLst/>
@@ -6011,14 +6037,14 @@
               <a:buNone/>
             </a:pPr>
             <a:r>
-              <a:rPr lang="en-US" sz="750" dirty="0">
+              <a:rPr lang="en-US" sz="1800" dirty="0">
                 <a:solidFill>
                   <a:srgbClr val="5A667D"/>
                 </a:solidFill>
               </a:rPr>
               <a:t>SYSEN 5493 final project  /  7</a:t>
             </a:r>
-            <a:endParaRPr lang="en-US" sz="750" dirty="0"/>
+            <a:endParaRPr lang="en-US" sz="1800" dirty="0"/>
           </a:p>
         </p:txBody>
       </p:sp>
@@ -6059,7 +6085,7 @@
     <p:bg>
       <p:bgPr>
         <a:solidFill>
-          <a:srgbClr val="F7F5EF"/>
+          <a:srgbClr val="FFFFFF"/>
         </a:solidFill>
       </p:bgPr>
     </p:bg>
@@ -6127,7 +6153,7 @@
               <a:buNone/>
             </a:pPr>
             <a:r>
-              <a:rPr lang="en-US" sz="900" b="1" dirty="0">
+              <a:rPr lang="en-US" sz="1800" b="1" dirty="0">
                 <a:solidFill>
                   <a:srgbClr val="5A667D"/>
                 </a:solidFill>
@@ -6137,7 +6163,7 @@
               </a:rPr>
               <a:t>CI/CD PROOF</a:t>
             </a:r>
-            <a:endParaRPr lang="en-US" sz="900" dirty="0"/>
+            <a:endParaRPr lang="en-US" sz="1800" dirty="0"/>
           </a:p>
         </p:txBody>
       </p:sp>
@@ -6168,7 +6194,7 @@
               <a:buNone/>
             </a:pPr>
             <a:r>
-              <a:rPr lang="en-US" sz="2600" b="1" dirty="0">
+              <a:rPr lang="en-US" sz="3000" b="1" dirty="0">
                 <a:solidFill>
                   <a:srgbClr val="172033"/>
                 </a:solidFill>
@@ -6178,7 +6204,7 @@
               </a:rPr>
               <a:t>CI makes the accessibility checker repeatable after every push.</a:t>
             </a:r>
-            <a:endParaRPr lang="en-US" sz="2600" dirty="0"/>
+            <a:endParaRPr lang="en-US" sz="3000" dirty="0"/>
           </a:p>
         </p:txBody>
       </p:sp>
@@ -6215,8 +6241,8 @@
         </p:nvSpPr>
         <p:spPr>
           <a:xfrm>
-            <a:off x="886968" y="2304288"/>
-            <a:ext cx="1463040" cy="201168"/>
+            <a:off x="886968" y="2240280"/>
+            <a:ext cx="1463040" cy="347472"/>
           </a:xfrm>
           <a:prstGeom prst="rect">
             <a:avLst/>
@@ -6234,14 +6260,14 @@
               <a:buNone/>
             </a:pPr>
             <a:r>
-              <a:rPr lang="en-US" sz="1100" b="1" dirty="0">
+              <a:rPr lang="en-US" sz="1800" b="1" dirty="0">
                 <a:solidFill>
                   <a:srgbClr val="172033"/>
                 </a:solidFill>
               </a:rPr>
               <a:t>Push / PR</a:t>
             </a:r>
-            <a:endParaRPr lang="en-US" sz="1100" dirty="0"/>
+            <a:endParaRPr lang="en-US" sz="1800" dirty="0"/>
           </a:p>
         </p:txBody>
       </p:sp>
@@ -6302,8 +6328,8 @@
         </p:nvSpPr>
         <p:spPr>
           <a:xfrm>
-            <a:off x="3127248" y="2304288"/>
-            <a:ext cx="1463040" cy="201168"/>
+            <a:off x="3127248" y="2240280"/>
+            <a:ext cx="1463040" cy="347472"/>
           </a:xfrm>
           <a:prstGeom prst="rect">
             <a:avLst/>
@@ -6321,14 +6347,14 @@
               <a:buNone/>
             </a:pPr>
             <a:r>
-              <a:rPr lang="en-US" sz="1100" b="1" dirty="0">
+              <a:rPr lang="en-US" sz="1800" b="1" dirty="0">
                 <a:solidFill>
                   <a:srgbClr val="172033"/>
                 </a:solidFill>
               </a:rPr>
               <a:t>Checkout</a:t>
             </a:r>
-            <a:endParaRPr lang="en-US" sz="1100" dirty="0"/>
+            <a:endParaRPr lang="en-US" sz="1800" dirty="0"/>
           </a:p>
         </p:txBody>
       </p:sp>
@@ -6389,8 +6415,8 @@
         </p:nvSpPr>
         <p:spPr>
           <a:xfrm>
-            <a:off x="5367528" y="2304288"/>
-            <a:ext cx="1463040" cy="201168"/>
+            <a:off x="5367528" y="2240280"/>
+            <a:ext cx="1463040" cy="347472"/>
           </a:xfrm>
           <a:prstGeom prst="rect">
             <a:avLst/>
@@ -6408,14 +6434,14 @@
               <a:buNone/>
             </a:pPr>
             <a:r>
-              <a:rPr lang="en-US" sz="1100" b="1" dirty="0">
+              <a:rPr lang="en-US" sz="1800" b="1" dirty="0">
                 <a:solidFill>
                   <a:srgbClr val="172033"/>
                 </a:solidFill>
               </a:rPr>
               <a:t>Python 3.11</a:t>
             </a:r>
-            <a:endParaRPr lang="en-US" sz="1100" dirty="0"/>
+            <a:endParaRPr lang="en-US" sz="1800" dirty="0"/>
           </a:p>
         </p:txBody>
       </p:sp>
@@ -6476,8 +6502,8 @@
         </p:nvSpPr>
         <p:spPr>
           <a:xfrm>
-            <a:off x="7607808" y="2304288"/>
-            <a:ext cx="1463040" cy="201168"/>
+            <a:off x="7607808" y="2240280"/>
+            <a:ext cx="1463040" cy="347472"/>
           </a:xfrm>
           <a:prstGeom prst="rect">
             <a:avLst/>
@@ -6495,14 +6521,14 @@
               <a:buNone/>
             </a:pPr>
             <a:r>
-              <a:rPr lang="en-US" sz="1100" b="1" dirty="0">
+              <a:rPr lang="en-US" sz="1800" b="1" dirty="0">
                 <a:solidFill>
                   <a:srgbClr val="009E73"/>
                 </a:solidFill>
               </a:rPr>
               <a:t>Unit tests</a:t>
             </a:r>
-            <a:endParaRPr lang="en-US" sz="1100" dirty="0"/>
+            <a:endParaRPr lang="en-US" sz="1800" dirty="0"/>
           </a:p>
         </p:txBody>
       </p:sp>
@@ -6563,8 +6589,8 @@
         </p:nvSpPr>
         <p:spPr>
           <a:xfrm>
-            <a:off x="9848088" y="2304288"/>
-            <a:ext cx="1463040" cy="201168"/>
+            <a:off x="9848088" y="2240280"/>
+            <a:ext cx="1463040" cy="347472"/>
           </a:xfrm>
           <a:prstGeom prst="rect">
             <a:avLst/>
@@ -6582,14 +6608,14 @@
               <a:buNone/>
             </a:pPr>
             <a:r>
-              <a:rPr lang="en-US" sz="1100" b="1" dirty="0">
+              <a:rPr lang="en-US" sz="1800" b="1" dirty="0">
                 <a:solidFill>
                   <a:srgbClr val="172033"/>
                 </a:solidFill>
               </a:rPr>
               <a:t>Demo audit</a:t>
             </a:r>
-            <a:endParaRPr lang="en-US" sz="1100" dirty="0"/>
+            <a:endParaRPr lang="en-US" sz="1800" dirty="0"/>
           </a:p>
         </p:txBody>
       </p:sp>
@@ -6647,14 +6673,14 @@
               <a:buNone/>
             </a:pPr>
             <a:r>
-              <a:rPr lang="en-US" sz="950" b="1" dirty="0">
+              <a:rPr lang="en-US" sz="1800" b="1" dirty="0">
                 <a:solidFill>
                   <a:srgbClr val="009E73"/>
                 </a:solidFill>
               </a:rPr>
               <a:t>README BADGE: GREEN AFTER GITHUB ACTIONS PASS</a:t>
             </a:r>
-            <a:endParaRPr lang="en-US" sz="950" dirty="0"/>
+            <a:endParaRPr lang="en-US" sz="1800" dirty="0"/>
           </a:p>
         </p:txBody>
       </p:sp>
@@ -6666,8 +6692,8 @@
         </p:nvSpPr>
         <p:spPr>
           <a:xfrm>
-            <a:off x="502920" y="6446520"/>
-            <a:ext cx="2926080" cy="182880"/>
+            <a:off x="502920" y="6263640"/>
+            <a:ext cx="4023360" cy="320040"/>
           </a:xfrm>
           <a:prstGeom prst="rect">
             <a:avLst/>
@@ -6683,14 +6709,14 @@
               <a:buNone/>
             </a:pPr>
             <a:r>
-              <a:rPr lang="en-US" sz="750" dirty="0">
+              <a:rPr lang="en-US" sz="1800" dirty="0">
                 <a:solidFill>
                   <a:srgbClr val="5A667D"/>
                 </a:solidFill>
               </a:rPr>
               <a:t>SYSEN 5493 final project  /  8</a:t>
             </a:r>
-            <a:endParaRPr lang="en-US" sz="750" dirty="0"/>
+            <a:endParaRPr lang="en-US" sz="1800" dirty="0"/>
           </a:p>
         </p:txBody>
       </p:sp>
@@ -6731,7 +6757,7 @@
     <p:bg>
       <p:bgPr>
         <a:solidFill>
-          <a:srgbClr val="F7F5EF"/>
+          <a:srgbClr val="FFFFFF"/>
         </a:solidFill>
       </p:bgPr>
     </p:bg>
@@ -6799,7 +6825,7 @@
               <a:buNone/>
             </a:pPr>
             <a:r>
-              <a:rPr lang="en-US" sz="900" b="1" dirty="0">
+              <a:rPr lang="en-US" sz="1800" b="1" dirty="0">
                 <a:solidFill>
                   <a:srgbClr val="5A667D"/>
                 </a:solidFill>
@@ -6809,7 +6835,7 @@
               </a:rPr>
               <a:t>REFLECTION</a:t>
             </a:r>
-            <a:endParaRPr lang="en-US" sz="900" dirty="0"/>
+            <a:endParaRPr lang="en-US" sz="1800" dirty="0"/>
           </a:p>
         </p:txBody>
       </p:sp>
@@ -6840,7 +6866,7 @@
               <a:buNone/>
             </a:pPr>
             <a:r>
-              <a:rPr lang="en-US" sz="2600" b="1" dirty="0">
+              <a:rPr lang="en-US" sz="3000" b="1" dirty="0">
                 <a:solidFill>
                   <a:srgbClr val="172033"/>
                 </a:solidFill>
@@ -6850,7 +6876,7 @@
               </a:rPr>
               <a:t>The hardest decision was policy, not syntax.</a:t>
             </a:r>
-            <a:endParaRPr lang="en-US" sz="2600" dirty="0"/>
+            <a:endParaRPr lang="en-US" sz="3000" dirty="0"/>
           </a:p>
         </p:txBody>
       </p:sp>
@@ -6882,14 +6908,14 @@
               <a:buChar char="•"/>
             </a:pPr>
             <a:r>
-              <a:rPr lang="en-US" sz="1350" dirty="0">
+              <a:rPr lang="en-US" sz="1800" dirty="0">
                 <a:solidFill>
                   <a:srgbClr val="172033"/>
                 </a:solidFill>
               </a:rPr>
               <a:t>The merge conflict forced a judgment call: what minimum font size should the checker enforce?</a:t>
             </a:r>
-            <a:endParaRPr lang="en-US" sz="1350" dirty="0"/>
+            <a:endParaRPr lang="en-US" sz="1800" dirty="0"/>
           </a:p>
           <a:p>
             <a:pPr marL="152400" indent="-152400">
@@ -6897,14 +6923,14 @@
               <a:buChar char="•"/>
             </a:pPr>
             <a:r>
-              <a:rPr lang="en-US" sz="1350" dirty="0">
+              <a:rPr lang="en-US" sz="1800" dirty="0">
                 <a:solidFill>
                   <a:srgbClr val="172033"/>
                 </a:solidFill>
               </a:rPr>
               <a:t>AI was useful as a second opinion, but the final standard needed to be explainable.</a:t>
             </a:r>
-            <a:endParaRPr lang="en-US" sz="1350" dirty="0"/>
+            <a:endParaRPr lang="en-US" sz="1800" dirty="0"/>
           </a:p>
           <a:p>
             <a:pPr marL="152400" indent="-152400">
@@ -6912,14 +6938,14 @@
               <a:buChar char="•"/>
             </a:pPr>
             <a:r>
-              <a:rPr lang="en-US" sz="1350" dirty="0">
+              <a:rPr lang="en-US" sz="1800" dirty="0">
                 <a:solidFill>
                   <a:srgbClr val="172033"/>
                 </a:solidFill>
               </a:rPr>
               <a:t>The better project was smaller: measurable checks beat an overbuilt black-box model.</a:t>
             </a:r>
-            <a:endParaRPr lang="en-US" sz="1350" dirty="0"/>
+            <a:endParaRPr lang="en-US" sz="1800" dirty="0"/>
           </a:p>
         </p:txBody>
       </p:sp>
@@ -6971,14 +6997,14 @@
               <a:buNone/>
             </a:pPr>
             <a:r>
-              <a:rPr lang="en-US" sz="2400" b="1" dirty="0">
+              <a:rPr lang="en-US" sz="2800" b="1" dirty="0">
                 <a:solidFill>
                   <a:srgbClr val="005AB5"/>
                 </a:solidFill>
               </a:rPr>
               <a:t>12 pt</a:t>
             </a:r>
-            <a:endParaRPr lang="en-US" sz="2400" dirty="0"/>
+            <a:endParaRPr lang="en-US" sz="2800" dirty="0"/>
           </a:p>
         </p:txBody>
       </p:sp>
@@ -7009,14 +7035,14 @@
               <a:buNone/>
             </a:pPr>
             <a:r>
-              <a:rPr lang="en-US" sz="950" dirty="0">
+              <a:rPr lang="en-US" sz="1800" dirty="0">
                 <a:solidFill>
                   <a:srgbClr val="5A667D"/>
                 </a:solidFill>
               </a:rPr>
               <a:t>resolved minimum font size</a:t>
             </a:r>
-            <a:endParaRPr lang="en-US" sz="950" dirty="0"/>
+            <a:endParaRPr lang="en-US" sz="1800" dirty="0"/>
           </a:p>
         </p:txBody>
       </p:sp>
@@ -7045,14 +7071,14 @@
               <a:buNone/>
             </a:pPr>
             <a:r>
-              <a:rPr lang="en-US" sz="2400" b="1" dirty="0">
+              <a:rPr lang="en-US" sz="2800" b="1" dirty="0">
                 <a:solidFill>
                   <a:srgbClr val="009E73"/>
                 </a:solidFill>
               </a:rPr>
               <a:t>0 deps</a:t>
             </a:r>
-            <a:endParaRPr lang="en-US" sz="2400" dirty="0"/>
+            <a:endParaRPr lang="en-US" sz="2800" dirty="0"/>
           </a:p>
         </p:txBody>
       </p:sp>
@@ -7083,14 +7109,14 @@
               <a:buNone/>
             </a:pPr>
             <a:r>
-              <a:rPr lang="en-US" sz="950" dirty="0">
+              <a:rPr lang="en-US" sz="1800" dirty="0">
                 <a:solidFill>
                   <a:srgbClr val="5A667D"/>
                 </a:solidFill>
               </a:rPr>
               <a:t>required to run local tests</a:t>
             </a:r>
-            <a:endParaRPr lang="en-US" sz="950" dirty="0"/>
+            <a:endParaRPr lang="en-US" sz="1800" dirty="0"/>
           </a:p>
         </p:txBody>
       </p:sp>
@@ -7119,14 +7145,14 @@
               <a:buNone/>
             </a:pPr>
             <a:r>
-              <a:rPr lang="en-US" sz="2400" b="1" dirty="0">
+              <a:rPr lang="en-US" sz="2800" b="1" dirty="0">
                 <a:solidFill>
                   <a:srgbClr val="DC3220"/>
                 </a:solidFill>
               </a:rPr>
               <a:t>4/4</a:t>
             </a:r>
-            <a:endParaRPr lang="en-US" sz="2400" dirty="0"/>
+            <a:endParaRPr lang="en-US" sz="2800" dirty="0"/>
           </a:p>
         </p:txBody>
       </p:sp>
@@ -7157,14 +7183,14 @@
               <a:buNone/>
             </a:pPr>
             <a:r>
-              <a:rPr lang="en-US" sz="950" dirty="0">
+              <a:rPr lang="en-US" sz="1800" dirty="0">
                 <a:solidFill>
                   <a:srgbClr val="5A667D"/>
                 </a:solidFill>
               </a:rPr>
               <a:t>requirements checked by good demo</a:t>
             </a:r>
-            <a:endParaRPr lang="en-US" sz="950" dirty="0"/>
+            <a:endParaRPr lang="en-US" sz="1800" dirty="0"/>
           </a:p>
         </p:txBody>
       </p:sp>
@@ -7176,8 +7202,8 @@
         </p:nvSpPr>
         <p:spPr>
           <a:xfrm>
-            <a:off x="502920" y="6446520"/>
-            <a:ext cx="2926080" cy="182880"/>
+            <a:off x="502920" y="6263640"/>
+            <a:ext cx="4023360" cy="320040"/>
           </a:xfrm>
           <a:prstGeom prst="rect">
             <a:avLst/>
@@ -7193,14 +7219,14 @@
               <a:buNone/>
             </a:pPr>
             <a:r>
-              <a:rPr lang="en-US" sz="750" dirty="0">
+              <a:rPr lang="en-US" sz="1800" dirty="0">
                 <a:solidFill>
                   <a:srgbClr val="5A667D"/>
                 </a:solidFill>
               </a:rPr>
               <a:t>SYSEN 5493 final project  /  9</a:t>
             </a:r>
-            <a:endParaRPr lang="en-US" sz="750" dirty="0"/>
+            <a:endParaRPr lang="en-US" sz="1800" dirty="0"/>
           </a:p>
         </p:txBody>
       </p:sp>

</xml_diff>